<commit_message>
Update the lec 1
</commit_message>
<xml_diff>
--- a/Slides/ADS_LEC_1.pptx
+++ b/Slides/ADS_LEC_1.pptx
@@ -8,6 +8,13 @@
     <p:sldId id="256" r:id="rId2"/>
     <p:sldId id="257" r:id="rId3"/>
     <p:sldId id="258" r:id="rId4"/>
+    <p:sldId id="259" r:id="rId5"/>
+    <p:sldId id="260" r:id="rId6"/>
+    <p:sldId id="261" r:id="rId7"/>
+    <p:sldId id="262" r:id="rId8"/>
+    <p:sldId id="263" r:id="rId9"/>
+    <p:sldId id="264" r:id="rId10"/>
+    <p:sldId id="265" r:id="rId11"/>
   </p:sldIdLst>
   <p:sldSz cx="12192000" cy="6858000"/>
   <p:notesSz cx="6858000" cy="9144000"/>
@@ -261,7 +268,7 @@
           <a:p>
             <a:fld id="{BC05FD56-F25B-46BA-80F6-CCD95C0515B8}" type="datetimeFigureOut">
               <a:rPr lang="en-US" smtClean="0"/>
-              <a:t>10/13/2025</a:t>
+              <a:t>10/14/2025</a:t>
             </a:fld>
             <a:endParaRPr lang="en-US"/>
           </a:p>
@@ -459,7 +466,7 @@
           <a:p>
             <a:fld id="{BC05FD56-F25B-46BA-80F6-CCD95C0515B8}" type="datetimeFigureOut">
               <a:rPr lang="en-US" smtClean="0"/>
-              <a:t>10/13/2025</a:t>
+              <a:t>10/14/2025</a:t>
             </a:fld>
             <a:endParaRPr lang="en-US"/>
           </a:p>
@@ -667,7 +674,7 @@
           <a:p>
             <a:fld id="{BC05FD56-F25B-46BA-80F6-CCD95C0515B8}" type="datetimeFigureOut">
               <a:rPr lang="en-US" smtClean="0"/>
-              <a:t>10/13/2025</a:t>
+              <a:t>10/14/2025</a:t>
             </a:fld>
             <a:endParaRPr lang="en-US"/>
           </a:p>
@@ -865,7 +872,7 @@
           <a:p>
             <a:fld id="{BC05FD56-F25B-46BA-80F6-CCD95C0515B8}" type="datetimeFigureOut">
               <a:rPr lang="en-US" smtClean="0"/>
-              <a:t>10/13/2025</a:t>
+              <a:t>10/14/2025</a:t>
             </a:fld>
             <a:endParaRPr lang="en-US"/>
           </a:p>
@@ -1140,7 +1147,7 @@
           <a:p>
             <a:fld id="{BC05FD56-F25B-46BA-80F6-CCD95C0515B8}" type="datetimeFigureOut">
               <a:rPr lang="en-US" smtClean="0"/>
-              <a:t>10/13/2025</a:t>
+              <a:t>10/14/2025</a:t>
             </a:fld>
             <a:endParaRPr lang="en-US"/>
           </a:p>
@@ -1405,7 +1412,7 @@
           <a:p>
             <a:fld id="{BC05FD56-F25B-46BA-80F6-CCD95C0515B8}" type="datetimeFigureOut">
               <a:rPr lang="en-US" smtClean="0"/>
-              <a:t>10/13/2025</a:t>
+              <a:t>10/14/2025</a:t>
             </a:fld>
             <a:endParaRPr lang="en-US"/>
           </a:p>
@@ -1817,7 +1824,7 @@
           <a:p>
             <a:fld id="{BC05FD56-F25B-46BA-80F6-CCD95C0515B8}" type="datetimeFigureOut">
               <a:rPr lang="en-US" smtClean="0"/>
-              <a:t>10/13/2025</a:t>
+              <a:t>10/14/2025</a:t>
             </a:fld>
             <a:endParaRPr lang="en-US"/>
           </a:p>
@@ -1958,7 +1965,7 @@
           <a:p>
             <a:fld id="{BC05FD56-F25B-46BA-80F6-CCD95C0515B8}" type="datetimeFigureOut">
               <a:rPr lang="en-US" smtClean="0"/>
-              <a:t>10/13/2025</a:t>
+              <a:t>10/14/2025</a:t>
             </a:fld>
             <a:endParaRPr lang="en-US"/>
           </a:p>
@@ -2071,7 +2078,7 @@
           <a:p>
             <a:fld id="{BC05FD56-F25B-46BA-80F6-CCD95C0515B8}" type="datetimeFigureOut">
               <a:rPr lang="en-US" smtClean="0"/>
-              <a:t>10/13/2025</a:t>
+              <a:t>10/14/2025</a:t>
             </a:fld>
             <a:endParaRPr lang="en-US"/>
           </a:p>
@@ -2382,7 +2389,7 @@
           <a:p>
             <a:fld id="{BC05FD56-F25B-46BA-80F6-CCD95C0515B8}" type="datetimeFigureOut">
               <a:rPr lang="en-US" smtClean="0"/>
-              <a:t>10/13/2025</a:t>
+              <a:t>10/14/2025</a:t>
             </a:fld>
             <a:endParaRPr lang="en-US"/>
           </a:p>
@@ -2670,7 +2677,7 @@
           <a:p>
             <a:fld id="{BC05FD56-F25B-46BA-80F6-CCD95C0515B8}" type="datetimeFigureOut">
               <a:rPr lang="en-US" smtClean="0"/>
-              <a:t>10/13/2025</a:t>
+              <a:t>10/14/2025</a:t>
             </a:fld>
             <a:endParaRPr lang="en-US"/>
           </a:p>
@@ -2911,7 +2918,7 @@
           <a:p>
             <a:fld id="{BC05FD56-F25B-46BA-80F6-CCD95C0515B8}" type="datetimeFigureOut">
               <a:rPr lang="en-US" smtClean="0"/>
-              <a:t>10/13/2025</a:t>
+              <a:t>10/14/2025</a:t>
             </a:fld>
             <a:endParaRPr lang="en-US"/>
           </a:p>
@@ -3409,6 +3416,398 @@
 </p:sld>
 </file>
 
+<file path=ppt/slides/slide10.xml><?xml version="1.0" encoding="utf-8"?>
+<p:sld xmlns:a="http://schemas.openxmlformats.org/drawingml/2006/main" xmlns:r="http://schemas.openxmlformats.org/officeDocument/2006/relationships" xmlns:p="http://schemas.openxmlformats.org/presentationml/2006/main">
+  <p:cSld>
+    <p:spTree>
+      <p:nvGrpSpPr>
+        <p:cNvPr id="1" name=""/>
+        <p:cNvGrpSpPr/>
+        <p:nvPr/>
+      </p:nvGrpSpPr>
+      <p:grpSpPr>
+        <a:xfrm>
+          <a:off x="0" y="0"/>
+          <a:ext cx="0" cy="0"/>
+          <a:chOff x="0" y="0"/>
+          <a:chExt cx="0" cy="0"/>
+        </a:xfrm>
+      </p:grpSpPr>
+      <p:sp>
+        <p:nvSpPr>
+          <p:cNvPr id="2" name="Title 1">
+            <a:extLst>
+              <a:ext uri="{FF2B5EF4-FFF2-40B4-BE49-F238E27FC236}">
+                <a16:creationId xmlns:a16="http://schemas.microsoft.com/office/drawing/2014/main" id="{4FBC0C2F-1EEB-A110-8E0D-66E857DDB47A}"/>
+              </a:ext>
+            </a:extLst>
+          </p:cNvPr>
+          <p:cNvSpPr>
+            <a:spLocks noGrp="1"/>
+          </p:cNvSpPr>
+          <p:nvPr>
+            <p:ph type="title"/>
+          </p:nvPr>
+        </p:nvSpPr>
+        <p:spPr>
+          <a:xfrm>
+            <a:off x="838200" y="255587"/>
+            <a:ext cx="10515600" cy="1072694"/>
+          </a:xfrm>
+        </p:spPr>
+        <p:txBody>
+          <a:bodyPr/>
+          <a:lstStyle/>
+          <a:p>
+            <a:pPr algn="ctr"/>
+            <a:r>
+              <a:rPr lang="en-US" b="1" u="sng" dirty="0"/>
+              <a:t>Stepwise Refinement</a:t>
+            </a:r>
+          </a:p>
+        </p:txBody>
+      </p:sp>
+      <p:sp>
+        <p:nvSpPr>
+          <p:cNvPr id="5" name="TextBox 4">
+            <a:extLst>
+              <a:ext uri="{FF2B5EF4-FFF2-40B4-BE49-F238E27FC236}">
+                <a16:creationId xmlns:a16="http://schemas.microsoft.com/office/drawing/2014/main" id="{D4C49532-AEE4-1BC9-9C85-AF0A37B955C0}"/>
+              </a:ext>
+            </a:extLst>
+          </p:cNvPr>
+          <p:cNvSpPr txBox="1"/>
+          <p:nvPr/>
+        </p:nvSpPr>
+        <p:spPr>
+          <a:xfrm>
+            <a:off x="838200" y="1294487"/>
+            <a:ext cx="9744075" cy="5139869"/>
+          </a:xfrm>
+          <a:prstGeom prst="rect">
+            <a:avLst/>
+          </a:prstGeom>
+          <a:noFill/>
+        </p:spPr>
+        <p:txBody>
+          <a:bodyPr wrap="square">
+            <a:spAutoFit/>
+          </a:bodyPr>
+          <a:lstStyle/>
+          <a:p>
+            <a:pPr>
+              <a:buFont typeface="Arial" panose="020B0604020202020204" pitchFamily="34" charset="0"/>
+              <a:buChar char="•"/>
+            </a:pPr>
+            <a:r>
+              <a:rPr lang="en-US" sz="2000" dirty="0"/>
+              <a:t>Breaking a big problem into smaller, easier parts.</a:t>
+            </a:r>
+          </a:p>
+          <a:p>
+            <a:pPr>
+              <a:buFont typeface="Arial" panose="020B0604020202020204" pitchFamily="34" charset="0"/>
+              <a:buChar char="•"/>
+            </a:pPr>
+            <a:endParaRPr lang="en-US" sz="2000" dirty="0"/>
+          </a:p>
+          <a:p>
+            <a:r>
+              <a:rPr lang="en-US" sz="2000" b="1" dirty="0"/>
+              <a:t>Example: </a:t>
+            </a:r>
+          </a:p>
+          <a:p>
+            <a:r>
+              <a:rPr lang="en-US" sz="2000" b="1" dirty="0"/>
+              <a:t> Goal:</a:t>
+            </a:r>
+            <a:r>
+              <a:rPr lang="en-US" sz="2000" dirty="0"/>
+              <a:t> Take a number as input and check whether it is positive, negative, or zero.</a:t>
+            </a:r>
+          </a:p>
+          <a:p>
+            <a:endParaRPr lang="en-US" sz="2000" dirty="0"/>
+          </a:p>
+          <a:p>
+            <a:pPr lvl="1" eaLnBrk="0" fontAlgn="base" hangingPunct="0">
+              <a:spcBef>
+                <a:spcPct val="0"/>
+              </a:spcBef>
+              <a:spcAft>
+                <a:spcPct val="0"/>
+              </a:spcAft>
+              <a:buFontTx/>
+              <a:buChar char="•"/>
+            </a:pPr>
+            <a:r>
+              <a:rPr lang="en-US" altLang="en-US" sz="1400" b="1" dirty="0">
+                <a:latin typeface="Arial" panose="020B0604020202020204" pitchFamily="34" charset="0"/>
+              </a:rPr>
+              <a:t> Start</a:t>
+            </a:r>
+            <a:endParaRPr lang="en-US" altLang="en-US" sz="2000" b="1" dirty="0">
+              <a:latin typeface="Arial" panose="020B0604020202020204" pitchFamily="34" charset="0"/>
+            </a:endParaRPr>
+          </a:p>
+          <a:p>
+            <a:pPr lvl="1" eaLnBrk="0" fontAlgn="base" hangingPunct="0">
+              <a:spcBef>
+                <a:spcPct val="0"/>
+              </a:spcBef>
+              <a:spcAft>
+                <a:spcPct val="0"/>
+              </a:spcAft>
+              <a:buFontTx/>
+              <a:buChar char="•"/>
+            </a:pPr>
+            <a:endParaRPr lang="en-US" altLang="en-US" sz="2000" dirty="0">
+              <a:latin typeface="Arial" panose="020B0604020202020204" pitchFamily="34" charset="0"/>
+            </a:endParaRPr>
+          </a:p>
+          <a:p>
+            <a:pPr lvl="1" eaLnBrk="0" fontAlgn="base" hangingPunct="0">
+              <a:spcBef>
+                <a:spcPct val="0"/>
+              </a:spcBef>
+              <a:spcAft>
+                <a:spcPct val="0"/>
+              </a:spcAft>
+              <a:buFontTx/>
+              <a:buChar char="•"/>
+            </a:pPr>
+            <a:r>
+              <a:rPr lang="en-US" altLang="en-US" sz="1400" b="1" dirty="0">
+                <a:latin typeface="Arial" panose="020B0604020202020204" pitchFamily="34" charset="0"/>
+              </a:rPr>
+              <a:t>Take input from the user</a:t>
+            </a:r>
+          </a:p>
+          <a:p>
+            <a:pPr lvl="1" eaLnBrk="0" fontAlgn="base" hangingPunct="0">
+              <a:spcBef>
+                <a:spcPct val="0"/>
+              </a:spcBef>
+              <a:spcAft>
+                <a:spcPct val="0"/>
+              </a:spcAft>
+              <a:buFontTx/>
+              <a:buChar char="•"/>
+            </a:pPr>
+            <a:endParaRPr lang="en-US" altLang="en-US" sz="1400" dirty="0">
+              <a:latin typeface="Arial" panose="020B0604020202020204" pitchFamily="34" charset="0"/>
+            </a:endParaRPr>
+          </a:p>
+          <a:p>
+            <a:pPr lvl="1" eaLnBrk="0" fontAlgn="base" hangingPunct="0">
+              <a:spcBef>
+                <a:spcPct val="0"/>
+              </a:spcBef>
+              <a:spcAft>
+                <a:spcPct val="0"/>
+              </a:spcAft>
+              <a:buFontTx/>
+              <a:buChar char="•"/>
+            </a:pPr>
+            <a:r>
+              <a:rPr lang="en-US" altLang="en-US" sz="1400" b="1" dirty="0">
+                <a:latin typeface="Arial" panose="020B0604020202020204" pitchFamily="34" charset="0"/>
+              </a:rPr>
+              <a:t> Check if the number is greater than 0</a:t>
+            </a:r>
+          </a:p>
+          <a:p>
+            <a:pPr lvl="1" eaLnBrk="0" fontAlgn="base" hangingPunct="0">
+              <a:spcBef>
+                <a:spcPct val="0"/>
+              </a:spcBef>
+              <a:spcAft>
+                <a:spcPct val="0"/>
+              </a:spcAft>
+              <a:buFontTx/>
+              <a:buChar char="•"/>
+            </a:pPr>
+            <a:endParaRPr lang="en-US" altLang="en-US" sz="1400" dirty="0">
+              <a:latin typeface="Arial" panose="020B0604020202020204" pitchFamily="34" charset="0"/>
+            </a:endParaRPr>
+          </a:p>
+          <a:p>
+            <a:pPr lvl="1" eaLnBrk="0" fontAlgn="base" hangingPunct="0">
+              <a:spcBef>
+                <a:spcPct val="0"/>
+              </a:spcBef>
+              <a:spcAft>
+                <a:spcPct val="0"/>
+              </a:spcAft>
+              <a:buFontTx/>
+              <a:buChar char="•"/>
+            </a:pPr>
+            <a:r>
+              <a:rPr lang="en-US" altLang="en-US" sz="1400" dirty="0">
+                <a:latin typeface="Arial" panose="020B0604020202020204" pitchFamily="34" charset="0"/>
+              </a:rPr>
+              <a:t> </a:t>
+            </a:r>
+            <a:r>
+              <a:rPr lang="en-US" altLang="en-US" sz="1400" b="1" dirty="0">
+                <a:latin typeface="Arial" panose="020B0604020202020204" pitchFamily="34" charset="0"/>
+              </a:rPr>
+              <a:t>If yes → print “Positive”</a:t>
+            </a:r>
+          </a:p>
+          <a:p>
+            <a:pPr lvl="1" eaLnBrk="0" fontAlgn="base" hangingPunct="0">
+              <a:spcBef>
+                <a:spcPct val="0"/>
+              </a:spcBef>
+              <a:spcAft>
+                <a:spcPct val="0"/>
+              </a:spcAft>
+              <a:buFontTx/>
+              <a:buChar char="•"/>
+            </a:pPr>
+            <a:endParaRPr lang="en-US" altLang="en-US" sz="1400" dirty="0">
+              <a:latin typeface="Arial" panose="020B0604020202020204" pitchFamily="34" charset="0"/>
+            </a:endParaRPr>
+          </a:p>
+          <a:p>
+            <a:pPr lvl="1" eaLnBrk="0" fontAlgn="base" hangingPunct="0">
+              <a:spcBef>
+                <a:spcPct val="0"/>
+              </a:spcBef>
+              <a:spcAft>
+                <a:spcPct val="0"/>
+              </a:spcAft>
+              <a:buFontTx/>
+              <a:buChar char="•"/>
+            </a:pPr>
+            <a:r>
+              <a:rPr lang="en-US" altLang="en-US" sz="1400" dirty="0">
+                <a:latin typeface="Arial" panose="020B0604020202020204" pitchFamily="34" charset="0"/>
+              </a:rPr>
+              <a:t> </a:t>
+            </a:r>
+            <a:r>
+              <a:rPr lang="en-US" altLang="en-US" sz="1400" b="1" dirty="0">
+                <a:latin typeface="Arial" panose="020B0604020202020204" pitchFamily="34" charset="0"/>
+              </a:rPr>
+              <a:t>Else if number is less than 0 → print “Negative”</a:t>
+            </a:r>
+          </a:p>
+          <a:p>
+            <a:pPr lvl="1" eaLnBrk="0" fontAlgn="base" hangingPunct="0">
+              <a:spcBef>
+                <a:spcPct val="0"/>
+              </a:spcBef>
+              <a:spcAft>
+                <a:spcPct val="0"/>
+              </a:spcAft>
+              <a:buFontTx/>
+              <a:buChar char="•"/>
+            </a:pPr>
+            <a:endParaRPr lang="en-US" altLang="en-US" sz="1400" dirty="0">
+              <a:latin typeface="Arial" panose="020B0604020202020204" pitchFamily="34" charset="0"/>
+            </a:endParaRPr>
+          </a:p>
+          <a:p>
+            <a:pPr lvl="1" eaLnBrk="0" fontAlgn="base" hangingPunct="0">
+              <a:spcBef>
+                <a:spcPct val="0"/>
+              </a:spcBef>
+              <a:spcAft>
+                <a:spcPct val="0"/>
+              </a:spcAft>
+              <a:buFontTx/>
+              <a:buChar char="•"/>
+            </a:pPr>
+            <a:r>
+              <a:rPr lang="en-US" altLang="en-US" sz="1400" dirty="0">
+                <a:latin typeface="Arial" panose="020B0604020202020204" pitchFamily="34" charset="0"/>
+              </a:rPr>
+              <a:t> </a:t>
+            </a:r>
+            <a:r>
+              <a:rPr lang="en-US" altLang="en-US" sz="1400" b="1" dirty="0">
+                <a:latin typeface="Arial" panose="020B0604020202020204" pitchFamily="34" charset="0"/>
+              </a:rPr>
+              <a:t>Else → print “Zero”</a:t>
+            </a:r>
+          </a:p>
+          <a:p>
+            <a:pPr lvl="1" eaLnBrk="0" fontAlgn="base" hangingPunct="0">
+              <a:spcBef>
+                <a:spcPct val="0"/>
+              </a:spcBef>
+              <a:spcAft>
+                <a:spcPct val="0"/>
+              </a:spcAft>
+              <a:buFontTx/>
+              <a:buChar char="•"/>
+            </a:pPr>
+            <a:endParaRPr lang="en-US" altLang="en-US" sz="1400" dirty="0">
+              <a:latin typeface="Arial" panose="020B0604020202020204" pitchFamily="34" charset="0"/>
+            </a:endParaRPr>
+          </a:p>
+          <a:p>
+            <a:pPr lvl="1" eaLnBrk="0" fontAlgn="base" hangingPunct="0">
+              <a:spcBef>
+                <a:spcPct val="0"/>
+              </a:spcBef>
+              <a:spcAft>
+                <a:spcPct val="0"/>
+              </a:spcAft>
+              <a:buFontTx/>
+              <a:buChar char="•"/>
+            </a:pPr>
+            <a:r>
+              <a:rPr lang="en-US" altLang="en-US" sz="1400" dirty="0">
+                <a:latin typeface="Arial" panose="020B0604020202020204" pitchFamily="34" charset="0"/>
+              </a:rPr>
+              <a:t> </a:t>
+            </a:r>
+            <a:r>
+              <a:rPr lang="en-US" altLang="en-US" sz="1400" b="1" dirty="0">
+                <a:latin typeface="Arial" panose="020B0604020202020204" pitchFamily="34" charset="0"/>
+              </a:rPr>
+              <a:t>End</a:t>
+            </a:r>
+          </a:p>
+          <a:p>
+            <a:endParaRPr lang="en-US" sz="2000" dirty="0"/>
+          </a:p>
+          <a:p>
+            <a:pPr>
+              <a:buNone/>
+            </a:pPr>
+            <a:r>
+              <a:rPr lang="en-US" sz="2000" dirty="0"/>
+              <a:t> In programming, we do the same — solve the problem </a:t>
+            </a:r>
+            <a:r>
+              <a:rPr lang="en-US" sz="2000" i="1" dirty="0"/>
+              <a:t>step by step</a:t>
+            </a:r>
+            <a:r>
+              <a:rPr lang="en-US" sz="2000" dirty="0"/>
+              <a:t>.</a:t>
+            </a:r>
+          </a:p>
+        </p:txBody>
+      </p:sp>
+    </p:spTree>
+    <p:extLst>
+      <p:ext uri="{BB962C8B-B14F-4D97-AF65-F5344CB8AC3E}">
+        <p14:creationId xmlns:p14="http://schemas.microsoft.com/office/powerpoint/2010/main" val="913562461"/>
+      </p:ext>
+    </p:extLst>
+  </p:cSld>
+  <p:clrMapOvr>
+    <a:masterClrMapping/>
+  </p:clrMapOvr>
+</p:sld>
+</file>
+
 <file path=ppt/slides/slide2.xml><?xml version="1.0" encoding="utf-8"?>
 <p:sld xmlns:a="http://schemas.openxmlformats.org/drawingml/2006/main" xmlns:r="http://schemas.openxmlformats.org/officeDocument/2006/relationships" xmlns:p="http://schemas.openxmlformats.org/presentationml/2006/main">
   <p:cSld>
@@ -3744,6 +4143,2318 @@
     <p:extLst>
       <p:ext uri="{BB962C8B-B14F-4D97-AF65-F5344CB8AC3E}">
         <p14:creationId xmlns:p14="http://schemas.microsoft.com/office/powerpoint/2010/main" val="816269882"/>
+      </p:ext>
+    </p:extLst>
+  </p:cSld>
+  <p:clrMapOvr>
+    <a:masterClrMapping/>
+  </p:clrMapOvr>
+</p:sld>
+</file>
+
+<file path=ppt/slides/slide4.xml><?xml version="1.0" encoding="utf-8"?>
+<p:sld xmlns:a="http://schemas.openxmlformats.org/drawingml/2006/main" xmlns:r="http://schemas.openxmlformats.org/officeDocument/2006/relationships" xmlns:p="http://schemas.openxmlformats.org/presentationml/2006/main">
+  <p:cSld>
+    <p:spTree>
+      <p:nvGrpSpPr>
+        <p:cNvPr id="1" name=""/>
+        <p:cNvGrpSpPr/>
+        <p:nvPr/>
+      </p:nvGrpSpPr>
+      <p:grpSpPr>
+        <a:xfrm>
+          <a:off x="0" y="0"/>
+          <a:ext cx="0" cy="0"/>
+          <a:chOff x="0" y="0"/>
+          <a:chExt cx="0" cy="0"/>
+        </a:xfrm>
+      </p:grpSpPr>
+      <p:sp>
+        <p:nvSpPr>
+          <p:cNvPr id="2" name="Title 1">
+            <a:extLst>
+              <a:ext uri="{FF2B5EF4-FFF2-40B4-BE49-F238E27FC236}">
+                <a16:creationId xmlns:a16="http://schemas.microsoft.com/office/drawing/2014/main" id="{C11C1F2D-E4CE-6D84-DFC8-879C8C7C653B}"/>
+              </a:ext>
+            </a:extLst>
+          </p:cNvPr>
+          <p:cNvSpPr>
+            <a:spLocks noGrp="1"/>
+          </p:cNvSpPr>
+          <p:nvPr>
+            <p:ph type="title"/>
+          </p:nvPr>
+        </p:nvSpPr>
+        <p:spPr>
+          <a:xfrm>
+            <a:off x="838200" y="365126"/>
+            <a:ext cx="10515600" cy="901700"/>
+          </a:xfrm>
+        </p:spPr>
+        <p:txBody>
+          <a:bodyPr/>
+          <a:lstStyle/>
+          <a:p>
+            <a:pPr algn="ctr"/>
+            <a:r>
+              <a:rPr lang="en-US" b="1" u="sng" dirty="0"/>
+              <a:t>Classification of Data Structures</a:t>
+            </a:r>
+          </a:p>
+        </p:txBody>
+      </p:sp>
+      <p:sp>
+        <p:nvSpPr>
+          <p:cNvPr id="3" name="Content Placeholder 2">
+            <a:extLst>
+              <a:ext uri="{FF2B5EF4-FFF2-40B4-BE49-F238E27FC236}">
+                <a16:creationId xmlns:a16="http://schemas.microsoft.com/office/drawing/2014/main" id="{007B6CD7-96E8-27E7-AC44-7C1455AA862F}"/>
+              </a:ext>
+            </a:extLst>
+          </p:cNvPr>
+          <p:cNvSpPr>
+            <a:spLocks noGrp="1"/>
+          </p:cNvSpPr>
+          <p:nvPr>
+            <p:ph idx="1"/>
+          </p:nvPr>
+        </p:nvSpPr>
+        <p:spPr>
+          <a:xfrm>
+            <a:off x="838200" y="1663700"/>
+            <a:ext cx="10515600" cy="1228725"/>
+          </a:xfrm>
+        </p:spPr>
+        <p:txBody>
+          <a:bodyPr>
+            <a:normAutofit/>
+          </a:bodyPr>
+          <a:lstStyle/>
+          <a:p>
+            <a:r>
+              <a:rPr lang="en-US" sz="2400" b="1" dirty="0"/>
+              <a:t>Data Structures are classified into:</a:t>
+            </a:r>
+          </a:p>
+          <a:p>
+            <a:pPr marL="914400" lvl="1" indent="-457200">
+              <a:buFont typeface="+mj-lt"/>
+              <a:buAutoNum type="arabicPeriod"/>
+            </a:pPr>
+            <a:r>
+              <a:rPr lang="en-US" sz="2000" dirty="0"/>
+              <a:t>Primitive Data Structures</a:t>
+            </a:r>
+          </a:p>
+          <a:p>
+            <a:pPr marL="914400" lvl="1" indent="-457200">
+              <a:buFont typeface="+mj-lt"/>
+              <a:buAutoNum type="arabicPeriod"/>
+            </a:pPr>
+            <a:r>
+              <a:rPr lang="en-US" sz="2000" dirty="0"/>
+              <a:t>Non-Primitive Data Structures</a:t>
+            </a:r>
+          </a:p>
+          <a:p>
+            <a:endParaRPr lang="en-US" sz="2400" dirty="0"/>
+          </a:p>
+        </p:txBody>
+      </p:sp>
+      <p:sp>
+        <p:nvSpPr>
+          <p:cNvPr id="4" name="Content Placeholder 2">
+            <a:extLst>
+              <a:ext uri="{FF2B5EF4-FFF2-40B4-BE49-F238E27FC236}">
+                <a16:creationId xmlns:a16="http://schemas.microsoft.com/office/drawing/2014/main" id="{5BF1EAF5-1EF4-3E92-55BB-7C529759CF80}"/>
+              </a:ext>
+            </a:extLst>
+          </p:cNvPr>
+          <p:cNvSpPr txBox="1">
+            <a:spLocks/>
+          </p:cNvSpPr>
+          <p:nvPr/>
+        </p:nvSpPr>
+        <p:spPr>
+          <a:xfrm>
+            <a:off x="838200" y="3251199"/>
+            <a:ext cx="5105400" cy="2867025"/>
+          </a:xfrm>
+          <a:prstGeom prst="rect">
+            <a:avLst/>
+          </a:prstGeom>
+        </p:spPr>
+        <p:txBody>
+          <a:bodyPr vert="horz" lIns="91440" tIns="45720" rIns="91440" bIns="45720" rtlCol="0">
+            <a:normAutofit fontScale="92500" lnSpcReduction="20000"/>
+          </a:bodyPr>
+          <a:lstStyle>
+            <a:lvl1pPr marL="228600" indent="-228600" algn="l" defTabSz="914400" rtl="0" eaLnBrk="1" latinLnBrk="0" hangingPunct="1">
+              <a:lnSpc>
+                <a:spcPct val="90000"/>
+              </a:lnSpc>
+              <a:spcBef>
+                <a:spcPts val="1000"/>
+              </a:spcBef>
+              <a:buFont typeface="Arial" panose="020B0604020202020204" pitchFamily="34" charset="0"/>
+              <a:buChar char="•"/>
+              <a:defRPr sz="2800" kern="1200">
+                <a:solidFill>
+                  <a:schemeClr val="tx1"/>
+                </a:solidFill>
+                <a:latin typeface="+mn-lt"/>
+                <a:ea typeface="+mn-ea"/>
+                <a:cs typeface="+mn-cs"/>
+              </a:defRPr>
+            </a:lvl1pPr>
+            <a:lvl2pPr marL="685800" indent="-228600" algn="l" defTabSz="914400" rtl="0" eaLnBrk="1" latinLnBrk="0" hangingPunct="1">
+              <a:lnSpc>
+                <a:spcPct val="90000"/>
+              </a:lnSpc>
+              <a:spcBef>
+                <a:spcPts val="500"/>
+              </a:spcBef>
+              <a:buFont typeface="Arial" panose="020B0604020202020204" pitchFamily="34" charset="0"/>
+              <a:buChar char="•"/>
+              <a:defRPr sz="2400" kern="1200">
+                <a:solidFill>
+                  <a:schemeClr val="tx1"/>
+                </a:solidFill>
+                <a:latin typeface="+mn-lt"/>
+                <a:ea typeface="+mn-ea"/>
+                <a:cs typeface="+mn-cs"/>
+              </a:defRPr>
+            </a:lvl2pPr>
+            <a:lvl3pPr marL="1143000" indent="-228600" algn="l" defTabSz="914400" rtl="0" eaLnBrk="1" latinLnBrk="0" hangingPunct="1">
+              <a:lnSpc>
+                <a:spcPct val="90000"/>
+              </a:lnSpc>
+              <a:spcBef>
+                <a:spcPts val="500"/>
+              </a:spcBef>
+              <a:buFont typeface="Arial" panose="020B0604020202020204" pitchFamily="34" charset="0"/>
+              <a:buChar char="•"/>
+              <a:defRPr sz="2000" kern="1200">
+                <a:solidFill>
+                  <a:schemeClr val="tx1"/>
+                </a:solidFill>
+                <a:latin typeface="+mn-lt"/>
+                <a:ea typeface="+mn-ea"/>
+                <a:cs typeface="+mn-cs"/>
+              </a:defRPr>
+            </a:lvl3pPr>
+            <a:lvl4pPr marL="1600200" indent="-228600" algn="l" defTabSz="914400" rtl="0" eaLnBrk="1" latinLnBrk="0" hangingPunct="1">
+              <a:lnSpc>
+                <a:spcPct val="90000"/>
+              </a:lnSpc>
+              <a:spcBef>
+                <a:spcPts val="500"/>
+              </a:spcBef>
+              <a:buFont typeface="Arial" panose="020B0604020202020204" pitchFamily="34" charset="0"/>
+              <a:buChar char="•"/>
+              <a:defRPr sz="1800" kern="1200">
+                <a:solidFill>
+                  <a:schemeClr val="tx1"/>
+                </a:solidFill>
+                <a:latin typeface="+mn-lt"/>
+                <a:ea typeface="+mn-ea"/>
+                <a:cs typeface="+mn-cs"/>
+              </a:defRPr>
+            </a:lvl4pPr>
+            <a:lvl5pPr marL="2057400" indent="-228600" algn="l" defTabSz="914400" rtl="0" eaLnBrk="1" latinLnBrk="0" hangingPunct="1">
+              <a:lnSpc>
+                <a:spcPct val="90000"/>
+              </a:lnSpc>
+              <a:spcBef>
+                <a:spcPts val="500"/>
+              </a:spcBef>
+              <a:buFont typeface="Arial" panose="020B0604020202020204" pitchFamily="34" charset="0"/>
+              <a:buChar char="•"/>
+              <a:defRPr sz="1800" kern="1200">
+                <a:solidFill>
+                  <a:schemeClr val="tx1"/>
+                </a:solidFill>
+                <a:latin typeface="+mn-lt"/>
+                <a:ea typeface="+mn-ea"/>
+                <a:cs typeface="+mn-cs"/>
+              </a:defRPr>
+            </a:lvl5pPr>
+            <a:lvl6pPr marL="2514600" indent="-228600" algn="l" defTabSz="914400" rtl="0" eaLnBrk="1" latinLnBrk="0" hangingPunct="1">
+              <a:lnSpc>
+                <a:spcPct val="90000"/>
+              </a:lnSpc>
+              <a:spcBef>
+                <a:spcPts val="500"/>
+              </a:spcBef>
+              <a:buFont typeface="Arial" panose="020B0604020202020204" pitchFamily="34" charset="0"/>
+              <a:buChar char="•"/>
+              <a:defRPr sz="1800" kern="1200">
+                <a:solidFill>
+                  <a:schemeClr val="tx1"/>
+                </a:solidFill>
+                <a:latin typeface="+mn-lt"/>
+                <a:ea typeface="+mn-ea"/>
+                <a:cs typeface="+mn-cs"/>
+              </a:defRPr>
+            </a:lvl6pPr>
+            <a:lvl7pPr marL="2971800" indent="-228600" algn="l" defTabSz="914400" rtl="0" eaLnBrk="1" latinLnBrk="0" hangingPunct="1">
+              <a:lnSpc>
+                <a:spcPct val="90000"/>
+              </a:lnSpc>
+              <a:spcBef>
+                <a:spcPts val="500"/>
+              </a:spcBef>
+              <a:buFont typeface="Arial" panose="020B0604020202020204" pitchFamily="34" charset="0"/>
+              <a:buChar char="•"/>
+              <a:defRPr sz="1800" kern="1200">
+                <a:solidFill>
+                  <a:schemeClr val="tx1"/>
+                </a:solidFill>
+                <a:latin typeface="+mn-lt"/>
+                <a:ea typeface="+mn-ea"/>
+                <a:cs typeface="+mn-cs"/>
+              </a:defRPr>
+            </a:lvl7pPr>
+            <a:lvl8pPr marL="3429000" indent="-228600" algn="l" defTabSz="914400" rtl="0" eaLnBrk="1" latinLnBrk="0" hangingPunct="1">
+              <a:lnSpc>
+                <a:spcPct val="90000"/>
+              </a:lnSpc>
+              <a:spcBef>
+                <a:spcPts val="500"/>
+              </a:spcBef>
+              <a:buFont typeface="Arial" panose="020B0604020202020204" pitchFamily="34" charset="0"/>
+              <a:buChar char="•"/>
+              <a:defRPr sz="1800" kern="1200">
+                <a:solidFill>
+                  <a:schemeClr val="tx1"/>
+                </a:solidFill>
+                <a:latin typeface="+mn-lt"/>
+                <a:ea typeface="+mn-ea"/>
+                <a:cs typeface="+mn-cs"/>
+              </a:defRPr>
+            </a:lvl8pPr>
+            <a:lvl9pPr marL="3886200" indent="-228600" algn="l" defTabSz="914400" rtl="0" eaLnBrk="1" latinLnBrk="0" hangingPunct="1">
+              <a:lnSpc>
+                <a:spcPct val="90000"/>
+              </a:lnSpc>
+              <a:spcBef>
+                <a:spcPts val="500"/>
+              </a:spcBef>
+              <a:buFont typeface="Arial" panose="020B0604020202020204" pitchFamily="34" charset="0"/>
+              <a:buChar char="•"/>
+              <a:defRPr sz="1800" kern="1200">
+                <a:solidFill>
+                  <a:schemeClr val="tx1"/>
+                </a:solidFill>
+                <a:latin typeface="+mn-lt"/>
+                <a:ea typeface="+mn-ea"/>
+                <a:cs typeface="+mn-cs"/>
+              </a:defRPr>
+            </a:lvl9pPr>
+          </a:lstStyle>
+          <a:p>
+            <a:r>
+              <a:rPr lang="en-US" sz="2400" b="1" dirty="0"/>
+              <a:t>Primitive Data Structures</a:t>
+            </a:r>
+          </a:p>
+          <a:p>
+            <a:pPr lvl="1"/>
+            <a:r>
+              <a:rPr lang="en-US" sz="2000" dirty="0"/>
+              <a:t>Store a </a:t>
+            </a:r>
+            <a:r>
+              <a:rPr lang="en-US" sz="2000" b="1" dirty="0"/>
+              <a:t>single value</a:t>
+            </a:r>
+            <a:r>
+              <a:rPr lang="en-US" sz="2000" dirty="0"/>
+              <a:t> at a time</a:t>
+            </a:r>
+          </a:p>
+          <a:p>
+            <a:pPr marL="457200" lvl="1" indent="0">
+              <a:buNone/>
+            </a:pPr>
+            <a:endParaRPr lang="en-US" sz="1600" dirty="0"/>
+          </a:p>
+          <a:p>
+            <a:r>
+              <a:rPr lang="en-US" sz="2000" b="1" dirty="0"/>
+              <a:t>Examples:</a:t>
+            </a:r>
+          </a:p>
+          <a:p>
+            <a:pPr lvl="1"/>
+            <a:r>
+              <a:rPr lang="en-US" sz="2000" dirty="0"/>
+              <a:t>Byte → 10,−5, </a:t>
+            </a:r>
+            <a:r>
+              <a:rPr lang="en-US" sz="2000" b="1" dirty="0"/>
+              <a:t>125                 </a:t>
+            </a:r>
+            <a:r>
+              <a:rPr lang="en-US" sz="2000" b="1" dirty="0">
+                <a:solidFill>
+                  <a:schemeClr val="bg1"/>
+                </a:solidFill>
+              </a:rPr>
+              <a:t>8 bits</a:t>
+            </a:r>
+            <a:r>
+              <a:rPr lang="en-US" sz="2000" dirty="0">
+                <a:solidFill>
+                  <a:schemeClr val="bg1"/>
+                </a:solidFill>
+              </a:rPr>
+              <a:t> (1 byte)</a:t>
+            </a:r>
+          </a:p>
+          <a:p>
+            <a:pPr lvl="1"/>
+            <a:r>
+              <a:rPr lang="en-US" sz="2000" dirty="0"/>
+              <a:t>int</a:t>
+            </a:r>
+            <a:r>
+              <a:rPr lang="en-US" sz="2200" dirty="0"/>
+              <a:t> → 10, 20, -5,            </a:t>
+            </a:r>
+            <a:r>
+              <a:rPr lang="en-US" sz="2000" dirty="0">
+                <a:solidFill>
+                  <a:schemeClr val="bg1"/>
+                </a:solidFill>
+              </a:rPr>
+              <a:t>8 bits </a:t>
+            </a:r>
+            <a:r>
+              <a:rPr lang="en-US" sz="2200" dirty="0">
+                <a:solidFill>
+                  <a:schemeClr val="bg1"/>
+                </a:solidFill>
+              </a:rPr>
+              <a:t>(2 bytes)</a:t>
+            </a:r>
+          </a:p>
+          <a:p>
+            <a:pPr lvl="1"/>
+            <a:r>
+              <a:rPr lang="en-US" sz="2000" dirty="0"/>
+              <a:t>float</a:t>
+            </a:r>
+            <a:r>
+              <a:rPr lang="en-US" sz="2200" dirty="0"/>
+              <a:t> → 3.14, -0.99       </a:t>
+            </a:r>
+            <a:r>
+              <a:rPr lang="en-US" sz="2000" dirty="0">
+                <a:solidFill>
+                  <a:schemeClr val="bg1"/>
+                </a:solidFill>
+              </a:rPr>
+              <a:t>32 bits (4 bytes)</a:t>
+            </a:r>
+          </a:p>
+          <a:p>
+            <a:pPr lvl="1"/>
+            <a:r>
+              <a:rPr lang="en-US" sz="2200" dirty="0"/>
+              <a:t>Long → 1234567890   </a:t>
+            </a:r>
+            <a:r>
+              <a:rPr lang="en-US" sz="2200" dirty="0">
+                <a:solidFill>
+                  <a:schemeClr val="bg1"/>
+                </a:solidFill>
+              </a:rPr>
+              <a:t>64 bits (2 bytes)</a:t>
+            </a:r>
+          </a:p>
+          <a:p>
+            <a:pPr lvl="1"/>
+            <a:r>
+              <a:rPr lang="en-US" sz="2000" dirty="0"/>
+              <a:t>char</a:t>
+            </a:r>
+            <a:r>
+              <a:rPr lang="en-US" sz="2200" dirty="0"/>
+              <a:t> → 'A', ‘b’	    </a:t>
+            </a:r>
+            <a:r>
+              <a:rPr lang="en-US" sz="2000" dirty="0">
+                <a:solidFill>
+                  <a:schemeClr val="bg1"/>
+                </a:solidFill>
+              </a:rPr>
+              <a:t>16 bits </a:t>
+            </a:r>
+            <a:r>
+              <a:rPr lang="en-US" sz="2200" dirty="0">
+                <a:solidFill>
+                  <a:schemeClr val="bg1"/>
+                </a:solidFill>
+              </a:rPr>
+              <a:t>(2 bytes)</a:t>
+            </a:r>
+          </a:p>
+          <a:p>
+            <a:pPr lvl="1"/>
+            <a:r>
+              <a:rPr lang="en-US" sz="2000" dirty="0"/>
+              <a:t>bool</a:t>
+            </a:r>
+            <a:r>
+              <a:rPr lang="en-US" sz="2200" dirty="0"/>
+              <a:t> → true / false       </a:t>
+            </a:r>
+            <a:r>
+              <a:rPr lang="en-US" sz="2000" dirty="0">
+                <a:solidFill>
+                  <a:schemeClr val="bg1"/>
+                </a:solidFill>
+              </a:rPr>
+              <a:t>1 bit</a:t>
+            </a:r>
+            <a:endParaRPr lang="en-US" sz="2200" b="1" dirty="0">
+              <a:solidFill>
+                <a:schemeClr val="bg1"/>
+              </a:solidFill>
+            </a:endParaRPr>
+          </a:p>
+        </p:txBody>
+      </p:sp>
+      <p:pic>
+        <p:nvPicPr>
+          <p:cNvPr id="1027" name="Picture 3" descr="Primitive Data Structure: Types &amp; its Operations">
+            <a:extLst>
+              <a:ext uri="{FF2B5EF4-FFF2-40B4-BE49-F238E27FC236}">
+                <a16:creationId xmlns:a16="http://schemas.microsoft.com/office/drawing/2014/main" id="{D2B666D9-0942-47DA-85AA-95A3E0C362E1}"/>
+              </a:ext>
+            </a:extLst>
+          </p:cNvPr>
+          <p:cNvPicPr>
+            <a:picLocks noChangeAspect="1" noChangeArrowheads="1"/>
+          </p:cNvPicPr>
+          <p:nvPr/>
+        </p:nvPicPr>
+        <p:blipFill>
+          <a:blip r:embed="rId2">
+            <a:extLst>
+              <a:ext uri="{28A0092B-C50C-407E-A947-70E740481C1C}">
+                <a14:useLocalDpi xmlns:a14="http://schemas.microsoft.com/office/drawing/2010/main" val="0"/>
+              </a:ext>
+            </a:extLst>
+          </a:blip>
+          <a:srcRect/>
+          <a:stretch>
+            <a:fillRect/>
+          </a:stretch>
+        </p:blipFill>
+        <p:spPr bwMode="auto">
+          <a:xfrm>
+            <a:off x="5740400" y="1266824"/>
+            <a:ext cx="5613400" cy="4851400"/>
+          </a:xfrm>
+          <a:prstGeom prst="rect">
+            <a:avLst/>
+          </a:prstGeom>
+          <a:noFill/>
+          <a:extLst>
+            <a:ext uri="{909E8E84-426E-40DD-AFC4-6F175D3DCCD1}">
+              <a14:hiddenFill xmlns:a14="http://schemas.microsoft.com/office/drawing/2010/main">
+                <a:solidFill>
+                  <a:srgbClr val="FFFFFF"/>
+                </a:solidFill>
+              </a14:hiddenFill>
+            </a:ext>
+          </a:extLst>
+        </p:spPr>
+      </p:pic>
+    </p:spTree>
+    <p:extLst>
+      <p:ext uri="{BB962C8B-B14F-4D97-AF65-F5344CB8AC3E}">
+        <p14:creationId xmlns:p14="http://schemas.microsoft.com/office/powerpoint/2010/main" val="2219611502"/>
+      </p:ext>
+    </p:extLst>
+  </p:cSld>
+  <p:clrMapOvr>
+    <a:masterClrMapping/>
+  </p:clrMapOvr>
+</p:sld>
+</file>
+
+<file path=ppt/slides/slide5.xml><?xml version="1.0" encoding="utf-8"?>
+<p:sld xmlns:a="http://schemas.openxmlformats.org/drawingml/2006/main" xmlns:r="http://schemas.openxmlformats.org/officeDocument/2006/relationships" xmlns:p="http://schemas.openxmlformats.org/presentationml/2006/main">
+  <p:cSld>
+    <p:spTree>
+      <p:nvGrpSpPr>
+        <p:cNvPr id="1" name=""/>
+        <p:cNvGrpSpPr/>
+        <p:nvPr/>
+      </p:nvGrpSpPr>
+      <p:grpSpPr>
+        <a:xfrm>
+          <a:off x="0" y="0"/>
+          <a:ext cx="0" cy="0"/>
+          <a:chOff x="0" y="0"/>
+          <a:chExt cx="0" cy="0"/>
+        </a:xfrm>
+      </p:grpSpPr>
+      <p:sp>
+        <p:nvSpPr>
+          <p:cNvPr id="2" name="Title 1">
+            <a:extLst>
+              <a:ext uri="{FF2B5EF4-FFF2-40B4-BE49-F238E27FC236}">
+                <a16:creationId xmlns:a16="http://schemas.microsoft.com/office/drawing/2014/main" id="{2CE9BAEE-DBDB-FFDA-3476-226148C44378}"/>
+              </a:ext>
+            </a:extLst>
+          </p:cNvPr>
+          <p:cNvSpPr>
+            <a:spLocks noGrp="1"/>
+          </p:cNvSpPr>
+          <p:nvPr>
+            <p:ph type="title"/>
+          </p:nvPr>
+        </p:nvSpPr>
+        <p:spPr/>
+        <p:txBody>
+          <a:bodyPr>
+            <a:normAutofit/>
+          </a:bodyPr>
+          <a:lstStyle/>
+          <a:p>
+            <a:r>
+              <a:rPr lang="en-US" sz="3200" b="1" dirty="0"/>
+              <a:t>Non-Primitive Data Structures</a:t>
+            </a:r>
+          </a:p>
+        </p:txBody>
+      </p:sp>
+      <p:sp>
+        <p:nvSpPr>
+          <p:cNvPr id="4" name="Content Placeholder 2">
+            <a:extLst>
+              <a:ext uri="{FF2B5EF4-FFF2-40B4-BE49-F238E27FC236}">
+                <a16:creationId xmlns:a16="http://schemas.microsoft.com/office/drawing/2014/main" id="{C4B1DCAD-3662-1385-531C-B8166BEAFB6A}"/>
+              </a:ext>
+            </a:extLst>
+          </p:cNvPr>
+          <p:cNvSpPr>
+            <a:spLocks noGrp="1"/>
+          </p:cNvSpPr>
+          <p:nvPr>
+            <p:ph idx="1"/>
+          </p:nvPr>
+        </p:nvSpPr>
+        <p:spPr>
+          <a:xfrm>
+            <a:off x="838200" y="1663700"/>
+            <a:ext cx="10515600" cy="1228725"/>
+          </a:xfrm>
+        </p:spPr>
+        <p:txBody>
+          <a:bodyPr>
+            <a:normAutofit/>
+          </a:bodyPr>
+          <a:lstStyle/>
+          <a:p>
+            <a:r>
+              <a:rPr lang="en-US" sz="2400" b="1" dirty="0"/>
+              <a:t>Non-Primitive Data Structures</a:t>
+            </a:r>
+          </a:p>
+          <a:p>
+            <a:pPr lvl="1"/>
+            <a:r>
+              <a:rPr lang="en-US" sz="2000" dirty="0"/>
+              <a:t>Derived from primitive data types.</a:t>
+            </a:r>
+          </a:p>
+          <a:p>
+            <a:pPr lvl="1"/>
+            <a:r>
+              <a:rPr lang="en-US" sz="2000" dirty="0"/>
+              <a:t>Used to store </a:t>
+            </a:r>
+            <a:r>
+              <a:rPr lang="en-US" sz="2000" b="1" dirty="0"/>
+              <a:t>large or complex</a:t>
+            </a:r>
+            <a:r>
+              <a:rPr lang="en-US" sz="2000" dirty="0"/>
+              <a:t> data efficiently.</a:t>
+            </a:r>
+          </a:p>
+        </p:txBody>
+      </p:sp>
+      <p:pic>
+        <p:nvPicPr>
+          <p:cNvPr id="11" name="Picture 10">
+            <a:extLst>
+              <a:ext uri="{FF2B5EF4-FFF2-40B4-BE49-F238E27FC236}">
+                <a16:creationId xmlns:a16="http://schemas.microsoft.com/office/drawing/2014/main" id="{5F4C6F79-558D-688B-41FD-A66524648531}"/>
+              </a:ext>
+            </a:extLst>
+          </p:cNvPr>
+          <p:cNvPicPr>
+            <a:picLocks noChangeAspect="1"/>
+          </p:cNvPicPr>
+          <p:nvPr/>
+        </p:nvPicPr>
+        <p:blipFill>
+          <a:blip r:embed="rId2"/>
+          <a:stretch>
+            <a:fillRect/>
+          </a:stretch>
+        </p:blipFill>
+        <p:spPr>
+          <a:xfrm>
+            <a:off x="6524625" y="731217"/>
+            <a:ext cx="5158187" cy="5164758"/>
+          </a:xfrm>
+          <a:prstGeom prst="rect">
+            <a:avLst/>
+          </a:prstGeom>
+        </p:spPr>
+      </p:pic>
+      <p:sp>
+        <p:nvSpPr>
+          <p:cNvPr id="13" name="TextBox 12">
+            <a:extLst>
+              <a:ext uri="{FF2B5EF4-FFF2-40B4-BE49-F238E27FC236}">
+                <a16:creationId xmlns:a16="http://schemas.microsoft.com/office/drawing/2014/main" id="{51241E69-4A4C-90BD-A9E8-9F41A7D00784}"/>
+              </a:ext>
+            </a:extLst>
+          </p:cNvPr>
+          <p:cNvSpPr txBox="1"/>
+          <p:nvPr/>
+        </p:nvSpPr>
+        <p:spPr>
+          <a:xfrm>
+            <a:off x="838200" y="4057650"/>
+            <a:ext cx="5048250" cy="1569660"/>
+          </a:xfrm>
+          <a:prstGeom prst="rect">
+            <a:avLst/>
+          </a:prstGeom>
+          <a:noFill/>
+        </p:spPr>
+        <p:txBody>
+          <a:bodyPr wrap="square">
+            <a:spAutoFit/>
+          </a:bodyPr>
+          <a:lstStyle/>
+          <a:p>
+            <a:pPr>
+              <a:buNone/>
+            </a:pPr>
+            <a:r>
+              <a:rPr lang="en-US" sz="2400" b="1" dirty="0"/>
+              <a:t>Examples:</a:t>
+            </a:r>
+            <a:endParaRPr lang="en-US" sz="2400" dirty="0"/>
+          </a:p>
+          <a:p>
+            <a:pPr>
+              <a:buFont typeface="+mj-lt"/>
+              <a:buAutoNum type="arabicPeriod"/>
+            </a:pPr>
+            <a:r>
+              <a:rPr lang="en-US" b="1" dirty="0"/>
+              <a:t>Array</a:t>
+            </a:r>
+            <a:r>
+              <a:rPr lang="en-US" dirty="0"/>
+              <a:t> – fixed size, easy access</a:t>
+            </a:r>
+          </a:p>
+          <a:p>
+            <a:pPr>
+              <a:buFont typeface="+mj-lt"/>
+              <a:buAutoNum type="arabicPeriod"/>
+            </a:pPr>
+            <a:r>
+              <a:rPr lang="en-US" b="1" dirty="0"/>
+              <a:t>Linked List</a:t>
+            </a:r>
+            <a:r>
+              <a:rPr lang="en-US" dirty="0"/>
+              <a:t> – flexible, can grow/shrink</a:t>
+            </a:r>
+          </a:p>
+          <a:p>
+            <a:pPr>
+              <a:buFont typeface="+mj-lt"/>
+              <a:buAutoNum type="arabicPeriod"/>
+            </a:pPr>
+            <a:r>
+              <a:rPr lang="en-US" b="1" dirty="0"/>
+              <a:t>Stack</a:t>
+            </a:r>
+            <a:r>
+              <a:rPr lang="en-US" dirty="0"/>
+              <a:t> – Last In First Out (LIFO)</a:t>
+            </a:r>
+          </a:p>
+          <a:p>
+            <a:pPr>
+              <a:buFont typeface="+mj-lt"/>
+              <a:buAutoNum type="arabicPeriod"/>
+            </a:pPr>
+            <a:r>
+              <a:rPr lang="en-US" b="1" dirty="0"/>
+              <a:t>Queue</a:t>
+            </a:r>
+            <a:r>
+              <a:rPr lang="en-US" dirty="0"/>
+              <a:t> – First In First Out (FIFO)</a:t>
+            </a:r>
+          </a:p>
+        </p:txBody>
+      </p:sp>
+    </p:spTree>
+    <p:extLst>
+      <p:ext uri="{BB962C8B-B14F-4D97-AF65-F5344CB8AC3E}">
+        <p14:creationId xmlns:p14="http://schemas.microsoft.com/office/powerpoint/2010/main" val="2910912264"/>
+      </p:ext>
+    </p:extLst>
+  </p:cSld>
+  <p:clrMapOvr>
+    <a:masterClrMapping/>
+  </p:clrMapOvr>
+</p:sld>
+</file>
+
+<file path=ppt/slides/slide6.xml><?xml version="1.0" encoding="utf-8"?>
+<p:sld xmlns:a="http://schemas.openxmlformats.org/drawingml/2006/main" xmlns:r="http://schemas.openxmlformats.org/officeDocument/2006/relationships" xmlns:p="http://schemas.openxmlformats.org/presentationml/2006/main">
+  <p:cSld>
+    <p:spTree>
+      <p:nvGrpSpPr>
+        <p:cNvPr id="1" name=""/>
+        <p:cNvGrpSpPr/>
+        <p:nvPr/>
+      </p:nvGrpSpPr>
+      <p:grpSpPr>
+        <a:xfrm>
+          <a:off x="0" y="0"/>
+          <a:ext cx="0" cy="0"/>
+          <a:chOff x="0" y="0"/>
+          <a:chExt cx="0" cy="0"/>
+        </a:xfrm>
+      </p:grpSpPr>
+      <p:sp>
+        <p:nvSpPr>
+          <p:cNvPr id="2" name="Title 1">
+            <a:extLst>
+              <a:ext uri="{FF2B5EF4-FFF2-40B4-BE49-F238E27FC236}">
+                <a16:creationId xmlns:a16="http://schemas.microsoft.com/office/drawing/2014/main" id="{A675FA1E-7FCF-8578-7E29-738FD5086DBB}"/>
+              </a:ext>
+            </a:extLst>
+          </p:cNvPr>
+          <p:cNvSpPr>
+            <a:spLocks noGrp="1"/>
+          </p:cNvSpPr>
+          <p:nvPr>
+            <p:ph type="title"/>
+          </p:nvPr>
+        </p:nvSpPr>
+        <p:spPr>
+          <a:xfrm>
+            <a:off x="838200" y="374650"/>
+            <a:ext cx="10515600" cy="1006475"/>
+          </a:xfrm>
+        </p:spPr>
+        <p:txBody>
+          <a:bodyPr/>
+          <a:lstStyle/>
+          <a:p>
+            <a:pPr algn="ctr"/>
+            <a:r>
+              <a:rPr lang="en-US" b="1" u="sng" dirty="0"/>
+              <a:t>Summary Table</a:t>
+            </a:r>
+          </a:p>
+        </p:txBody>
+      </p:sp>
+      <p:graphicFrame>
+        <p:nvGraphicFramePr>
+          <p:cNvPr id="4" name="Content Placeholder 3">
+            <a:extLst>
+              <a:ext uri="{FF2B5EF4-FFF2-40B4-BE49-F238E27FC236}">
+                <a16:creationId xmlns:a16="http://schemas.microsoft.com/office/drawing/2014/main" id="{661526F5-9652-EF18-31C3-41753209AE0E}"/>
+              </a:ext>
+            </a:extLst>
+          </p:cNvPr>
+          <p:cNvGraphicFramePr>
+            <a:graphicFrameLocks noGrp="1"/>
+          </p:cNvGraphicFramePr>
+          <p:nvPr>
+            <p:ph idx="1"/>
+            <p:extLst>
+              <p:ext uri="{D42A27DB-BD31-4B8C-83A1-F6EECF244321}">
+                <p14:modId xmlns:p14="http://schemas.microsoft.com/office/powerpoint/2010/main" val="335983848"/>
+              </p:ext>
+            </p:extLst>
+          </p:nvPr>
+        </p:nvGraphicFramePr>
+        <p:xfrm>
+          <a:off x="838200" y="1285875"/>
+          <a:ext cx="10515600" cy="2371726"/>
+        </p:xfrm>
+        <a:graphic>
+          <a:graphicData uri="http://schemas.openxmlformats.org/drawingml/2006/table">
+            <a:tbl>
+              <a:tblPr/>
+              <a:tblGrid>
+                <a:gridCol w="2103120">
+                  <a:extLst>
+                    <a:ext uri="{9D8B030D-6E8A-4147-A177-3AD203B41FA5}">
+                      <a16:colId xmlns:a16="http://schemas.microsoft.com/office/drawing/2014/main" val="2066510170"/>
+                    </a:ext>
+                  </a:extLst>
+                </a:gridCol>
+                <a:gridCol w="2103120">
+                  <a:extLst>
+                    <a:ext uri="{9D8B030D-6E8A-4147-A177-3AD203B41FA5}">
+                      <a16:colId xmlns:a16="http://schemas.microsoft.com/office/drawing/2014/main" val="1820799480"/>
+                    </a:ext>
+                  </a:extLst>
+                </a:gridCol>
+                <a:gridCol w="2103120">
+                  <a:extLst>
+                    <a:ext uri="{9D8B030D-6E8A-4147-A177-3AD203B41FA5}">
+                      <a16:colId xmlns:a16="http://schemas.microsoft.com/office/drawing/2014/main" val="2968583828"/>
+                    </a:ext>
+                  </a:extLst>
+                </a:gridCol>
+                <a:gridCol w="2103120">
+                  <a:extLst>
+                    <a:ext uri="{9D8B030D-6E8A-4147-A177-3AD203B41FA5}">
+                      <a16:colId xmlns:a16="http://schemas.microsoft.com/office/drawing/2014/main" val="226964482"/>
+                    </a:ext>
+                  </a:extLst>
+                </a:gridCol>
+                <a:gridCol w="2103120">
+                  <a:extLst>
+                    <a:ext uri="{9D8B030D-6E8A-4147-A177-3AD203B41FA5}">
+                      <a16:colId xmlns:a16="http://schemas.microsoft.com/office/drawing/2014/main" val="3440013384"/>
+                    </a:ext>
+                  </a:extLst>
+                </a:gridCol>
+              </a:tblGrid>
+              <a:tr h="499311">
+                <a:tc>
+                  <a:txBody>
+                    <a:bodyPr/>
+                    <a:lstStyle/>
+                    <a:p>
+                      <a:pPr>
+                        <a:buNone/>
+                      </a:pPr>
+                      <a:r>
+                        <a:rPr lang="en-US" b="1" dirty="0"/>
+                        <a:t>Category</a:t>
+                      </a:r>
+                    </a:p>
+                  </a:txBody>
+                  <a:tcPr anchor="ctr">
+                    <a:lnL>
+                      <a:noFill/>
+                    </a:lnL>
+                    <a:lnR>
+                      <a:noFill/>
+                    </a:lnR>
+                    <a:lnT>
+                      <a:noFill/>
+                    </a:lnT>
+                    <a:lnB>
+                      <a:noFill/>
+                    </a:lnB>
+                    <a:noFill/>
+                  </a:tcPr>
+                </a:tc>
+                <a:tc>
+                  <a:txBody>
+                    <a:bodyPr/>
+                    <a:lstStyle/>
+                    <a:p>
+                      <a:pPr>
+                        <a:buNone/>
+                      </a:pPr>
+                      <a:r>
+                        <a:rPr lang="en-US" b="1" dirty="0"/>
+                        <a:t>Type</a:t>
+                      </a:r>
+                    </a:p>
+                  </a:txBody>
+                  <a:tcPr anchor="ctr">
+                    <a:lnL>
+                      <a:noFill/>
+                    </a:lnL>
+                    <a:lnR>
+                      <a:noFill/>
+                    </a:lnR>
+                    <a:lnT>
+                      <a:noFill/>
+                    </a:lnT>
+                    <a:lnB>
+                      <a:noFill/>
+                    </a:lnB>
+                    <a:noFill/>
+                  </a:tcPr>
+                </a:tc>
+                <a:tc>
+                  <a:txBody>
+                    <a:bodyPr/>
+                    <a:lstStyle/>
+                    <a:p>
+                      <a:pPr>
+                        <a:buNone/>
+                      </a:pPr>
+                      <a:r>
+                        <a:rPr lang="en-US" b="1" dirty="0"/>
+                        <a:t>Description</a:t>
+                      </a:r>
+                    </a:p>
+                  </a:txBody>
+                  <a:tcPr anchor="ctr">
+                    <a:lnL>
+                      <a:noFill/>
+                    </a:lnL>
+                    <a:lnR>
+                      <a:noFill/>
+                    </a:lnR>
+                    <a:lnT>
+                      <a:noFill/>
+                    </a:lnT>
+                    <a:lnB>
+                      <a:noFill/>
+                    </a:lnB>
+                    <a:noFill/>
+                  </a:tcPr>
+                </a:tc>
+                <a:tc>
+                  <a:txBody>
+                    <a:bodyPr/>
+                    <a:lstStyle/>
+                    <a:p>
+                      <a:pPr>
+                        <a:buNone/>
+                      </a:pPr>
+                      <a:r>
+                        <a:rPr lang="en-US" b="1" dirty="0"/>
+                        <a:t>Example</a:t>
+                      </a:r>
+                    </a:p>
+                  </a:txBody>
+                  <a:tcPr anchor="ctr">
+                    <a:lnL>
+                      <a:noFill/>
+                    </a:lnL>
+                    <a:lnR>
+                      <a:noFill/>
+                    </a:lnR>
+                    <a:lnT>
+                      <a:noFill/>
+                    </a:lnT>
+                    <a:lnB>
+                      <a:noFill/>
+                    </a:lnB>
+                    <a:noFill/>
+                  </a:tcPr>
+                </a:tc>
+                <a:tc>
+                  <a:txBody>
+                    <a:bodyPr/>
+                    <a:lstStyle/>
+                    <a:p>
+                      <a:pPr>
+                        <a:buNone/>
+                      </a:pPr>
+                      <a:r>
+                        <a:rPr lang="en-US" b="1" dirty="0"/>
+                        <a:t>Analogy</a:t>
+                      </a:r>
+                    </a:p>
+                  </a:txBody>
+                  <a:tcPr anchor="ctr">
+                    <a:lnL>
+                      <a:noFill/>
+                    </a:lnL>
+                    <a:lnR>
+                      <a:noFill/>
+                    </a:lnR>
+                    <a:lnT>
+                      <a:noFill/>
+                    </a:lnT>
+                    <a:lnB>
+                      <a:noFill/>
+                    </a:lnB>
+                    <a:noFill/>
+                  </a:tcPr>
+                </a:tc>
+                <a:extLst>
+                  <a:ext uri="{0D108BD9-81ED-4DB2-BD59-A6C34878D82A}">
+                    <a16:rowId xmlns:a16="http://schemas.microsoft.com/office/drawing/2014/main" val="1478207423"/>
+                  </a:ext>
+                </a:extLst>
+              </a:tr>
+              <a:tr h="499311">
+                <a:tc>
+                  <a:txBody>
+                    <a:bodyPr/>
+                    <a:lstStyle/>
+                    <a:p>
+                      <a:pPr>
+                        <a:buNone/>
+                      </a:pPr>
+                      <a:r>
+                        <a:rPr lang="en-US"/>
+                        <a:t>Primitive</a:t>
+                      </a:r>
+                    </a:p>
+                  </a:txBody>
+                  <a:tcPr anchor="ctr">
+                    <a:lnL>
+                      <a:noFill/>
+                    </a:lnL>
+                    <a:lnR>
+                      <a:noFill/>
+                    </a:lnR>
+                    <a:lnT>
+                      <a:noFill/>
+                    </a:lnT>
+                    <a:lnB>
+                      <a:noFill/>
+                    </a:lnB>
+                    <a:noFill/>
+                  </a:tcPr>
+                </a:tc>
+                <a:tc>
+                  <a:txBody>
+                    <a:bodyPr/>
+                    <a:lstStyle/>
+                    <a:p>
+                      <a:pPr>
+                        <a:buNone/>
+                      </a:pPr>
+                      <a:r>
+                        <a:rPr lang="en-US"/>
+                        <a:t>int, float, char, bool</a:t>
+                      </a:r>
+                    </a:p>
+                  </a:txBody>
+                  <a:tcPr anchor="ctr">
+                    <a:lnL>
+                      <a:noFill/>
+                    </a:lnL>
+                    <a:lnR>
+                      <a:noFill/>
+                    </a:lnR>
+                    <a:lnT>
+                      <a:noFill/>
+                    </a:lnT>
+                    <a:lnB>
+                      <a:noFill/>
+                    </a:lnB>
+                    <a:noFill/>
+                  </a:tcPr>
+                </a:tc>
+                <a:tc>
+                  <a:txBody>
+                    <a:bodyPr/>
+                    <a:lstStyle/>
+                    <a:p>
+                      <a:pPr>
+                        <a:buNone/>
+                      </a:pPr>
+                      <a:r>
+                        <a:rPr lang="en-US" dirty="0"/>
+                        <a:t>Basic types</a:t>
+                      </a:r>
+                    </a:p>
+                  </a:txBody>
+                  <a:tcPr anchor="ctr">
+                    <a:lnL>
+                      <a:noFill/>
+                    </a:lnL>
+                    <a:lnR>
+                      <a:noFill/>
+                    </a:lnR>
+                    <a:lnT>
+                      <a:noFill/>
+                    </a:lnT>
+                    <a:lnB>
+                      <a:noFill/>
+                    </a:lnB>
+                    <a:noFill/>
+                  </a:tcPr>
+                </a:tc>
+                <a:tc>
+                  <a:txBody>
+                    <a:bodyPr/>
+                    <a:lstStyle/>
+                    <a:p>
+                      <a:pPr>
+                        <a:buNone/>
+                      </a:pPr>
+                      <a:r>
+                        <a:rPr lang="en-US">
+                          <a:latin typeface="Courier New" panose="02070309020205020404" pitchFamily="49" charset="0"/>
+                        </a:rPr>
+                        <a:t>int x = 5</a:t>
+                      </a:r>
+                      <a:endParaRPr lang="en-US"/>
+                    </a:p>
+                  </a:txBody>
+                  <a:tcPr anchor="ctr">
+                    <a:lnL>
+                      <a:noFill/>
+                    </a:lnL>
+                    <a:lnR>
+                      <a:noFill/>
+                    </a:lnR>
+                    <a:lnT>
+                      <a:noFill/>
+                    </a:lnT>
+                    <a:lnB>
+                      <a:noFill/>
+                    </a:lnB>
+                    <a:noFill/>
+                  </a:tcPr>
+                </a:tc>
+                <a:tc>
+                  <a:txBody>
+                    <a:bodyPr/>
+                    <a:lstStyle/>
+                    <a:p>
+                      <a:pPr>
+                        <a:buNone/>
+                      </a:pPr>
+                      <a:r>
+                        <a:rPr lang="en-US"/>
+                        <a:t>Ingredients</a:t>
+                      </a:r>
+                    </a:p>
+                  </a:txBody>
+                  <a:tcPr anchor="ctr">
+                    <a:lnL>
+                      <a:noFill/>
+                    </a:lnL>
+                    <a:lnR>
+                      <a:noFill/>
+                    </a:lnR>
+                    <a:lnT>
+                      <a:noFill/>
+                    </a:lnT>
+                    <a:lnB>
+                      <a:noFill/>
+                    </a:lnB>
+                    <a:noFill/>
+                  </a:tcPr>
+                </a:tc>
+                <a:extLst>
+                  <a:ext uri="{0D108BD9-81ED-4DB2-BD59-A6C34878D82A}">
+                    <a16:rowId xmlns:a16="http://schemas.microsoft.com/office/drawing/2014/main" val="4045760128"/>
+                  </a:ext>
+                </a:extLst>
+              </a:tr>
+              <a:tr h="499311">
+                <a:tc>
+                  <a:txBody>
+                    <a:bodyPr/>
+                    <a:lstStyle/>
+                    <a:p>
+                      <a:pPr>
+                        <a:buNone/>
+                      </a:pPr>
+                      <a:r>
+                        <a:rPr lang="en-US"/>
+                        <a:t>Non-Primitive</a:t>
+                      </a:r>
+                    </a:p>
+                  </a:txBody>
+                  <a:tcPr anchor="ctr">
+                    <a:lnL>
+                      <a:noFill/>
+                    </a:lnL>
+                    <a:lnR>
+                      <a:noFill/>
+                    </a:lnR>
+                    <a:lnT>
+                      <a:noFill/>
+                    </a:lnT>
+                    <a:lnB>
+                      <a:noFill/>
+                    </a:lnB>
+                    <a:noFill/>
+                  </a:tcPr>
+                </a:tc>
+                <a:tc>
+                  <a:txBody>
+                    <a:bodyPr/>
+                    <a:lstStyle/>
+                    <a:p>
+                      <a:pPr>
+                        <a:buNone/>
+                      </a:pPr>
+                      <a:r>
+                        <a:rPr lang="en-US"/>
+                        <a:t>Linear</a:t>
+                      </a:r>
+                    </a:p>
+                  </a:txBody>
+                  <a:tcPr anchor="ctr">
+                    <a:lnL>
+                      <a:noFill/>
+                    </a:lnL>
+                    <a:lnR>
+                      <a:noFill/>
+                    </a:lnR>
+                    <a:lnT>
+                      <a:noFill/>
+                    </a:lnT>
+                    <a:lnB>
+                      <a:noFill/>
+                    </a:lnB>
+                    <a:noFill/>
+                  </a:tcPr>
+                </a:tc>
+                <a:tc>
+                  <a:txBody>
+                    <a:bodyPr/>
+                    <a:lstStyle/>
+                    <a:p>
+                      <a:pPr>
+                        <a:buNone/>
+                      </a:pPr>
+                      <a:r>
+                        <a:rPr lang="en-US"/>
+                        <a:t>Sequential storage</a:t>
+                      </a:r>
+                    </a:p>
+                  </a:txBody>
+                  <a:tcPr anchor="ctr">
+                    <a:lnL>
+                      <a:noFill/>
+                    </a:lnL>
+                    <a:lnR>
+                      <a:noFill/>
+                    </a:lnR>
+                    <a:lnT>
+                      <a:noFill/>
+                    </a:lnT>
+                    <a:lnB>
+                      <a:noFill/>
+                    </a:lnB>
+                    <a:noFill/>
+                  </a:tcPr>
+                </a:tc>
+                <a:tc>
+                  <a:txBody>
+                    <a:bodyPr/>
+                    <a:lstStyle/>
+                    <a:p>
+                      <a:pPr>
+                        <a:buNone/>
+                      </a:pPr>
+                      <a:r>
+                        <a:rPr lang="en-US"/>
+                        <a:t>Array, Stack</a:t>
+                      </a:r>
+                    </a:p>
+                  </a:txBody>
+                  <a:tcPr anchor="ctr">
+                    <a:lnL>
+                      <a:noFill/>
+                    </a:lnL>
+                    <a:lnR>
+                      <a:noFill/>
+                    </a:lnR>
+                    <a:lnT>
+                      <a:noFill/>
+                    </a:lnT>
+                    <a:lnB>
+                      <a:noFill/>
+                    </a:lnB>
+                    <a:noFill/>
+                  </a:tcPr>
+                </a:tc>
+                <a:tc>
+                  <a:txBody>
+                    <a:bodyPr/>
+                    <a:lstStyle/>
+                    <a:p>
+                      <a:pPr>
+                        <a:buNone/>
+                      </a:pPr>
+                      <a:r>
+                        <a:rPr lang="en-US"/>
+                        <a:t>Queue / Shelf</a:t>
+                      </a:r>
+                    </a:p>
+                  </a:txBody>
+                  <a:tcPr anchor="ctr">
+                    <a:lnL>
+                      <a:noFill/>
+                    </a:lnL>
+                    <a:lnR>
+                      <a:noFill/>
+                    </a:lnR>
+                    <a:lnT>
+                      <a:noFill/>
+                    </a:lnT>
+                    <a:lnB>
+                      <a:noFill/>
+                    </a:lnB>
+                    <a:noFill/>
+                  </a:tcPr>
+                </a:tc>
+                <a:extLst>
+                  <a:ext uri="{0D108BD9-81ED-4DB2-BD59-A6C34878D82A}">
+                    <a16:rowId xmlns:a16="http://schemas.microsoft.com/office/drawing/2014/main" val="216676478"/>
+                  </a:ext>
+                </a:extLst>
+              </a:tr>
+              <a:tr h="873793">
+                <a:tc>
+                  <a:txBody>
+                    <a:bodyPr/>
+                    <a:lstStyle/>
+                    <a:p>
+                      <a:pPr>
+                        <a:buNone/>
+                      </a:pPr>
+                      <a:r>
+                        <a:rPr lang="en-US"/>
+                        <a:t>Non-Primitive</a:t>
+                      </a:r>
+                    </a:p>
+                  </a:txBody>
+                  <a:tcPr anchor="ctr">
+                    <a:lnL>
+                      <a:noFill/>
+                    </a:lnL>
+                    <a:lnR>
+                      <a:noFill/>
+                    </a:lnR>
+                    <a:lnT>
+                      <a:noFill/>
+                    </a:lnT>
+                    <a:lnB>
+                      <a:noFill/>
+                    </a:lnB>
+                    <a:noFill/>
+                  </a:tcPr>
+                </a:tc>
+                <a:tc>
+                  <a:txBody>
+                    <a:bodyPr/>
+                    <a:lstStyle/>
+                    <a:p>
+                      <a:pPr>
+                        <a:buNone/>
+                      </a:pPr>
+                      <a:r>
+                        <a:rPr lang="en-US"/>
+                        <a:t>Non-Linear</a:t>
+                      </a:r>
+                    </a:p>
+                  </a:txBody>
+                  <a:tcPr anchor="ctr">
+                    <a:lnL>
+                      <a:noFill/>
+                    </a:lnL>
+                    <a:lnR>
+                      <a:noFill/>
+                    </a:lnR>
+                    <a:lnT>
+                      <a:noFill/>
+                    </a:lnT>
+                    <a:lnB>
+                      <a:noFill/>
+                    </a:lnB>
+                    <a:noFill/>
+                  </a:tcPr>
+                </a:tc>
+                <a:tc>
+                  <a:txBody>
+                    <a:bodyPr/>
+                    <a:lstStyle/>
+                    <a:p>
+                      <a:pPr>
+                        <a:buNone/>
+                      </a:pPr>
+                      <a:r>
+                        <a:rPr lang="en-US"/>
+                        <a:t>Hierarchical / Network</a:t>
+                      </a:r>
+                    </a:p>
+                  </a:txBody>
+                  <a:tcPr anchor="ctr">
+                    <a:lnL>
+                      <a:noFill/>
+                    </a:lnL>
+                    <a:lnR>
+                      <a:noFill/>
+                    </a:lnR>
+                    <a:lnT>
+                      <a:noFill/>
+                    </a:lnT>
+                    <a:lnB>
+                      <a:noFill/>
+                    </a:lnB>
+                    <a:noFill/>
+                  </a:tcPr>
+                </a:tc>
+                <a:tc>
+                  <a:txBody>
+                    <a:bodyPr/>
+                    <a:lstStyle/>
+                    <a:p>
+                      <a:pPr>
+                        <a:buNone/>
+                      </a:pPr>
+                      <a:r>
+                        <a:rPr lang="en-US"/>
+                        <a:t>Tree, Graph</a:t>
+                      </a:r>
+                    </a:p>
+                  </a:txBody>
+                  <a:tcPr anchor="ctr">
+                    <a:lnL>
+                      <a:noFill/>
+                    </a:lnL>
+                    <a:lnR>
+                      <a:noFill/>
+                    </a:lnR>
+                    <a:lnT>
+                      <a:noFill/>
+                    </a:lnT>
+                    <a:lnB>
+                      <a:noFill/>
+                    </a:lnB>
+                    <a:noFill/>
+                  </a:tcPr>
+                </a:tc>
+                <a:tc>
+                  <a:txBody>
+                    <a:bodyPr/>
+                    <a:lstStyle/>
+                    <a:p>
+                      <a:pPr>
+                        <a:buNone/>
+                      </a:pPr>
+                      <a:r>
+                        <a:rPr lang="en-US" dirty="0"/>
+                        <a:t>Family tree / Map</a:t>
+                      </a:r>
+                    </a:p>
+                  </a:txBody>
+                  <a:tcPr anchor="ctr">
+                    <a:lnL>
+                      <a:noFill/>
+                    </a:lnL>
+                    <a:lnR>
+                      <a:noFill/>
+                    </a:lnR>
+                    <a:lnT>
+                      <a:noFill/>
+                    </a:lnT>
+                    <a:lnB>
+                      <a:noFill/>
+                    </a:lnB>
+                    <a:noFill/>
+                  </a:tcPr>
+                </a:tc>
+                <a:extLst>
+                  <a:ext uri="{0D108BD9-81ED-4DB2-BD59-A6C34878D82A}">
+                    <a16:rowId xmlns:a16="http://schemas.microsoft.com/office/drawing/2014/main" val="341568645"/>
+                  </a:ext>
+                </a:extLst>
+              </a:tr>
+            </a:tbl>
+          </a:graphicData>
+        </a:graphic>
+      </p:graphicFrame>
+      <p:sp>
+        <p:nvSpPr>
+          <p:cNvPr id="6" name="TextBox 5">
+            <a:extLst>
+              <a:ext uri="{FF2B5EF4-FFF2-40B4-BE49-F238E27FC236}">
+                <a16:creationId xmlns:a16="http://schemas.microsoft.com/office/drawing/2014/main" id="{D295A0AE-B9E0-DC42-2B2A-734209DD5B51}"/>
+              </a:ext>
+            </a:extLst>
+          </p:cNvPr>
+          <p:cNvSpPr txBox="1"/>
+          <p:nvPr/>
+        </p:nvSpPr>
+        <p:spPr>
+          <a:xfrm>
+            <a:off x="838200" y="3939659"/>
+            <a:ext cx="6096000" cy="400110"/>
+          </a:xfrm>
+          <a:prstGeom prst="rect">
+            <a:avLst/>
+          </a:prstGeom>
+          <a:noFill/>
+        </p:spPr>
+        <p:txBody>
+          <a:bodyPr wrap="square">
+            <a:spAutoFit/>
+          </a:bodyPr>
+          <a:lstStyle/>
+          <a:p>
+            <a:r>
+              <a:rPr lang="en-US" sz="2000" b="1" dirty="0"/>
+              <a:t>Key Takeaways:</a:t>
+            </a:r>
+          </a:p>
+        </p:txBody>
+      </p:sp>
+      <p:sp>
+        <p:nvSpPr>
+          <p:cNvPr id="8" name="TextBox 7">
+            <a:extLst>
+              <a:ext uri="{FF2B5EF4-FFF2-40B4-BE49-F238E27FC236}">
+                <a16:creationId xmlns:a16="http://schemas.microsoft.com/office/drawing/2014/main" id="{5AC809CF-7A72-AB71-CBD1-0127242DAC43}"/>
+              </a:ext>
+            </a:extLst>
+          </p:cNvPr>
+          <p:cNvSpPr txBox="1"/>
+          <p:nvPr/>
+        </p:nvSpPr>
+        <p:spPr>
+          <a:xfrm>
+            <a:off x="1485900" y="4339769"/>
+            <a:ext cx="9525000" cy="1200329"/>
+          </a:xfrm>
+          <a:prstGeom prst="rect">
+            <a:avLst/>
+          </a:prstGeom>
+          <a:noFill/>
+        </p:spPr>
+        <p:txBody>
+          <a:bodyPr wrap="square">
+            <a:spAutoFit/>
+          </a:bodyPr>
+          <a:lstStyle/>
+          <a:p>
+            <a:r>
+              <a:rPr lang="en-US" dirty="0"/>
+              <a:t>✅ Data structures help in </a:t>
+            </a:r>
+            <a:r>
+              <a:rPr lang="en-US" b="1" dirty="0"/>
+              <a:t>storing and organizing data efficiently</a:t>
+            </a:r>
+            <a:br>
+              <a:rPr lang="en-US" dirty="0"/>
+            </a:br>
+            <a:r>
+              <a:rPr lang="en-US" dirty="0"/>
+              <a:t>✅ Two main types: </a:t>
+            </a:r>
+            <a:r>
+              <a:rPr lang="en-US" b="1" dirty="0"/>
+              <a:t>Primitive</a:t>
+            </a:r>
+            <a:r>
+              <a:rPr lang="en-US" dirty="0"/>
+              <a:t> and </a:t>
+            </a:r>
+            <a:r>
+              <a:rPr lang="en-US" b="1" dirty="0"/>
+              <a:t>Non-Primitive</a:t>
+            </a:r>
+            <a:br>
+              <a:rPr lang="en-US" dirty="0"/>
+            </a:br>
+            <a:r>
+              <a:rPr lang="en-US" dirty="0"/>
+              <a:t>✅ Non-Primitive further divided into </a:t>
+            </a:r>
+            <a:r>
+              <a:rPr lang="en-US" b="1" dirty="0"/>
+              <a:t>Linear</a:t>
+            </a:r>
+            <a:r>
+              <a:rPr lang="en-US" dirty="0"/>
+              <a:t> and </a:t>
+            </a:r>
+            <a:r>
+              <a:rPr lang="en-US" b="1" dirty="0"/>
+              <a:t>Non-Linear</a:t>
+            </a:r>
+            <a:br>
+              <a:rPr lang="en-US" dirty="0"/>
+            </a:br>
+            <a:r>
+              <a:rPr lang="en-US" dirty="0"/>
+              <a:t>✅ Each structure has its own </a:t>
+            </a:r>
+            <a:r>
+              <a:rPr lang="en-US" b="1" dirty="0"/>
+              <a:t>advantages and real-life analogies</a:t>
+            </a:r>
+            <a:endParaRPr lang="en-US" dirty="0"/>
+          </a:p>
+        </p:txBody>
+      </p:sp>
+    </p:spTree>
+    <p:extLst>
+      <p:ext uri="{BB962C8B-B14F-4D97-AF65-F5344CB8AC3E}">
+        <p14:creationId xmlns:p14="http://schemas.microsoft.com/office/powerpoint/2010/main" val="3811553887"/>
+      </p:ext>
+    </p:extLst>
+  </p:cSld>
+  <p:clrMapOvr>
+    <a:masterClrMapping/>
+  </p:clrMapOvr>
+</p:sld>
+</file>
+
+<file path=ppt/slides/slide7.xml><?xml version="1.0" encoding="utf-8"?>
+<p:sld xmlns:a="http://schemas.openxmlformats.org/drawingml/2006/main" xmlns:r="http://schemas.openxmlformats.org/officeDocument/2006/relationships" xmlns:p="http://schemas.openxmlformats.org/presentationml/2006/main">
+  <p:cSld>
+    <p:spTree>
+      <p:nvGrpSpPr>
+        <p:cNvPr id="1" name=""/>
+        <p:cNvGrpSpPr/>
+        <p:nvPr/>
+      </p:nvGrpSpPr>
+      <p:grpSpPr>
+        <a:xfrm>
+          <a:off x="0" y="0"/>
+          <a:ext cx="0" cy="0"/>
+          <a:chOff x="0" y="0"/>
+          <a:chExt cx="0" cy="0"/>
+        </a:xfrm>
+      </p:grpSpPr>
+      <p:sp>
+        <p:nvSpPr>
+          <p:cNvPr id="2" name="Title 1">
+            <a:extLst>
+              <a:ext uri="{FF2B5EF4-FFF2-40B4-BE49-F238E27FC236}">
+                <a16:creationId xmlns:a16="http://schemas.microsoft.com/office/drawing/2014/main" id="{6D11FD7B-0391-14CD-1798-028896468394}"/>
+              </a:ext>
+            </a:extLst>
+          </p:cNvPr>
+          <p:cNvSpPr>
+            <a:spLocks noGrp="1"/>
+          </p:cNvSpPr>
+          <p:nvPr>
+            <p:ph type="title"/>
+          </p:nvPr>
+        </p:nvSpPr>
+        <p:spPr/>
+        <p:txBody>
+          <a:bodyPr/>
+          <a:lstStyle/>
+          <a:p>
+            <a:pPr algn="ctr"/>
+            <a:r>
+              <a:rPr lang="en-US" b="1" u="sng" dirty="0"/>
+              <a:t>What is an Algorithm?</a:t>
+            </a:r>
+          </a:p>
+        </p:txBody>
+      </p:sp>
+      <p:sp>
+        <p:nvSpPr>
+          <p:cNvPr id="3" name="Content Placeholder 2">
+            <a:extLst>
+              <a:ext uri="{FF2B5EF4-FFF2-40B4-BE49-F238E27FC236}">
+                <a16:creationId xmlns:a16="http://schemas.microsoft.com/office/drawing/2014/main" id="{249A3E5C-57A8-3DD8-654F-11B71397658C}"/>
+              </a:ext>
+            </a:extLst>
+          </p:cNvPr>
+          <p:cNvSpPr>
+            <a:spLocks noGrp="1"/>
+          </p:cNvSpPr>
+          <p:nvPr>
+            <p:ph idx="1"/>
+          </p:nvPr>
+        </p:nvSpPr>
+        <p:spPr>
+          <a:xfrm>
+            <a:off x="838200" y="1825625"/>
+            <a:ext cx="10515600" cy="908050"/>
+          </a:xfrm>
+        </p:spPr>
+        <p:txBody>
+          <a:bodyPr>
+            <a:normAutofit/>
+          </a:bodyPr>
+          <a:lstStyle/>
+          <a:p>
+            <a:r>
+              <a:rPr lang="en-US" sz="2400" dirty="0"/>
+              <a:t>An </a:t>
+            </a:r>
+            <a:r>
+              <a:rPr lang="en-US" sz="2400" b="1" dirty="0"/>
+              <a:t>algorithm</a:t>
+            </a:r>
+            <a:r>
+              <a:rPr lang="en-US" sz="2400" dirty="0"/>
+              <a:t> is a set of step-by-step instructions to solve a problem.</a:t>
+            </a:r>
+          </a:p>
+        </p:txBody>
+      </p:sp>
+      <p:sp>
+        <p:nvSpPr>
+          <p:cNvPr id="5" name="TextBox 4">
+            <a:extLst>
+              <a:ext uri="{FF2B5EF4-FFF2-40B4-BE49-F238E27FC236}">
+                <a16:creationId xmlns:a16="http://schemas.microsoft.com/office/drawing/2014/main" id="{A416CF44-C528-CD0B-57F4-9430D38B0DF9}"/>
+              </a:ext>
+            </a:extLst>
+          </p:cNvPr>
+          <p:cNvSpPr txBox="1"/>
+          <p:nvPr/>
+        </p:nvSpPr>
+        <p:spPr>
+          <a:xfrm>
+            <a:off x="1019175" y="2733675"/>
+            <a:ext cx="6096000" cy="2215991"/>
+          </a:xfrm>
+          <a:prstGeom prst="rect">
+            <a:avLst/>
+          </a:prstGeom>
+          <a:noFill/>
+        </p:spPr>
+        <p:txBody>
+          <a:bodyPr wrap="square">
+            <a:spAutoFit/>
+          </a:bodyPr>
+          <a:lstStyle/>
+          <a:p>
+            <a:pPr>
+              <a:buNone/>
+            </a:pPr>
+            <a:r>
+              <a:rPr lang="en-US" sz="2400" b="1" dirty="0"/>
+              <a:t>Example:</a:t>
+            </a:r>
+            <a:br>
+              <a:rPr lang="en-US" sz="2400" dirty="0"/>
+            </a:br>
+            <a:r>
+              <a:rPr lang="en-US" sz="2400" dirty="0"/>
+              <a:t>   </a:t>
+            </a:r>
+            <a:r>
+              <a:rPr lang="en-US" b="1" dirty="0"/>
+              <a:t>Making tea algorithm:</a:t>
+            </a:r>
+            <a:endParaRPr lang="en-US" dirty="0"/>
+          </a:p>
+          <a:p>
+            <a:pPr lvl="1">
+              <a:buFont typeface="+mj-lt"/>
+              <a:buAutoNum type="arabicPeriod"/>
+            </a:pPr>
+            <a:r>
+              <a:rPr lang="en-US" dirty="0"/>
+              <a:t>Boil water</a:t>
+            </a:r>
+          </a:p>
+          <a:p>
+            <a:pPr lvl="1">
+              <a:buFont typeface="+mj-lt"/>
+              <a:buAutoNum type="arabicPeriod"/>
+            </a:pPr>
+            <a:r>
+              <a:rPr lang="en-US" dirty="0"/>
+              <a:t>Add tea leaves</a:t>
+            </a:r>
+          </a:p>
+          <a:p>
+            <a:pPr lvl="1">
+              <a:buFont typeface="+mj-lt"/>
+              <a:buAutoNum type="arabicPeriod"/>
+            </a:pPr>
+            <a:r>
+              <a:rPr lang="en-US" dirty="0"/>
+              <a:t>Add milk and sugar</a:t>
+            </a:r>
+          </a:p>
+          <a:p>
+            <a:pPr lvl="1">
+              <a:buFont typeface="+mj-lt"/>
+              <a:buAutoNum type="arabicPeriod"/>
+            </a:pPr>
+            <a:r>
+              <a:rPr lang="en-US" dirty="0"/>
+              <a:t>Stir</a:t>
+            </a:r>
+          </a:p>
+          <a:p>
+            <a:pPr lvl="1">
+              <a:buFont typeface="+mj-lt"/>
+              <a:buAutoNum type="arabicPeriod"/>
+            </a:pPr>
+            <a:r>
+              <a:rPr lang="en-US" dirty="0"/>
+              <a:t>Serve</a:t>
+            </a:r>
+          </a:p>
+        </p:txBody>
+      </p:sp>
+    </p:spTree>
+    <p:extLst>
+      <p:ext uri="{BB962C8B-B14F-4D97-AF65-F5344CB8AC3E}">
+        <p14:creationId xmlns:p14="http://schemas.microsoft.com/office/powerpoint/2010/main" val="250314883"/>
+      </p:ext>
+    </p:extLst>
+  </p:cSld>
+  <p:clrMapOvr>
+    <a:masterClrMapping/>
+  </p:clrMapOvr>
+</p:sld>
+</file>
+
+<file path=ppt/slides/slide8.xml><?xml version="1.0" encoding="utf-8"?>
+<p:sld xmlns:a="http://schemas.openxmlformats.org/drawingml/2006/main" xmlns:r="http://schemas.openxmlformats.org/officeDocument/2006/relationships" xmlns:p="http://schemas.openxmlformats.org/presentationml/2006/main">
+  <p:cSld>
+    <p:spTree>
+      <p:nvGrpSpPr>
+        <p:cNvPr id="1" name=""/>
+        <p:cNvGrpSpPr/>
+        <p:nvPr/>
+      </p:nvGrpSpPr>
+      <p:grpSpPr>
+        <a:xfrm>
+          <a:off x="0" y="0"/>
+          <a:ext cx="0" cy="0"/>
+          <a:chOff x="0" y="0"/>
+          <a:chExt cx="0" cy="0"/>
+        </a:xfrm>
+      </p:grpSpPr>
+      <p:sp>
+        <p:nvSpPr>
+          <p:cNvPr id="2" name="Title 1">
+            <a:extLst>
+              <a:ext uri="{FF2B5EF4-FFF2-40B4-BE49-F238E27FC236}">
+                <a16:creationId xmlns:a16="http://schemas.microsoft.com/office/drawing/2014/main" id="{B780A158-45D8-1358-49D3-7B6897212CF6}"/>
+              </a:ext>
+            </a:extLst>
+          </p:cNvPr>
+          <p:cNvSpPr>
+            <a:spLocks noGrp="1"/>
+          </p:cNvSpPr>
+          <p:nvPr>
+            <p:ph type="title"/>
+          </p:nvPr>
+        </p:nvSpPr>
+        <p:spPr/>
+        <p:txBody>
+          <a:bodyPr/>
+          <a:lstStyle/>
+          <a:p>
+            <a:pPr algn="ctr"/>
+            <a:r>
+              <a:rPr lang="en-US" b="1" u="sng" dirty="0"/>
+              <a:t>The Big Picture</a:t>
+            </a:r>
+          </a:p>
+        </p:txBody>
+      </p:sp>
+      <p:sp>
+        <p:nvSpPr>
+          <p:cNvPr id="6" name="Rectangle 3">
+            <a:extLst>
+              <a:ext uri="{FF2B5EF4-FFF2-40B4-BE49-F238E27FC236}">
+                <a16:creationId xmlns:a16="http://schemas.microsoft.com/office/drawing/2014/main" id="{8D5FD90A-C06C-2AC6-ACDF-210ED0B77EC5}"/>
+              </a:ext>
+            </a:extLst>
+          </p:cNvPr>
+          <p:cNvSpPr>
+            <a:spLocks noChangeArrowheads="1"/>
+          </p:cNvSpPr>
+          <p:nvPr/>
+        </p:nvSpPr>
+        <p:spPr bwMode="auto">
+          <a:xfrm>
+            <a:off x="1138237" y="2241918"/>
+            <a:ext cx="9915525" cy="1631216"/>
+          </a:xfrm>
+          <a:prstGeom prst="rect">
+            <a:avLst/>
+          </a:prstGeom>
+          <a:noFill/>
+          <a:ln>
+            <a:noFill/>
+          </a:ln>
+          <a:effectLst/>
+          <a:extLst>
+            <a:ext uri="{909E8E84-426E-40DD-AFC4-6F175D3DCCD1}">
+              <a14:hiddenFill xmlns:a14="http://schemas.microsoft.com/office/drawing/2010/main">
+                <a:solidFill>
+                  <a:schemeClr val="accent1"/>
+                </a:solidFill>
+              </a14:hiddenFill>
+            </a:ext>
+            <a:ext uri="{91240B29-F687-4F45-9708-019B960494DF}">
+              <a14:hiddenLine xmlns:a14="http://schemas.microsoft.com/office/drawing/2010/main" w="9525">
+                <a:solidFill>
+                  <a:schemeClr val="tx1"/>
+                </a:solidFill>
+                <a:miter lim="800000"/>
+                <a:headEnd/>
+                <a:tailEnd/>
+              </a14:hiddenLine>
+            </a:ext>
+            <a:ext uri="{AF507438-7753-43E0-B8FC-AC1667EBCBE1}">
+              <a14:hiddenEffects xmlns:a14="http://schemas.microsoft.com/office/drawing/2010/main">
+                <a:effectLst>
+                  <a:outerShdw dist="35921" dir="2700000" algn="ctr" rotWithShape="0">
+                    <a:schemeClr val="bg2"/>
+                  </a:outerShdw>
+                </a:effectLst>
+              </a14:hiddenEffects>
+            </a:ext>
+          </a:extLst>
+        </p:spPr>
+        <p:txBody>
+          <a:bodyPr vert="horz" wrap="square" lIns="91440" tIns="45720" rIns="91440" bIns="45720" numCol="1" anchor="ctr" anchorCtr="0" compatLnSpc="1">
+            <a:prstTxWarp prst="textNoShape">
+              <a:avLst/>
+            </a:prstTxWarp>
+            <a:spAutoFit/>
+          </a:bodyPr>
+          <a:lstStyle/>
+          <a:p>
+            <a:pPr marL="0" marR="0" lvl="0" indent="0" algn="l" defTabSz="914400" rtl="0" eaLnBrk="0" fontAlgn="base" latinLnBrk="0" hangingPunct="0">
+              <a:lnSpc>
+                <a:spcPct val="100000"/>
+              </a:lnSpc>
+              <a:spcBef>
+                <a:spcPct val="0"/>
+              </a:spcBef>
+              <a:spcAft>
+                <a:spcPct val="0"/>
+              </a:spcAft>
+              <a:buClrTx/>
+              <a:buSzTx/>
+              <a:buFontTx/>
+              <a:buChar char="•"/>
+              <a:tabLst/>
+            </a:pPr>
+            <a:r>
+              <a:rPr kumimoji="0" lang="en-US" altLang="en-US" sz="2000" b="1" i="0" u="none" strike="noStrike" cap="none" normalizeH="0" baseline="0" dirty="0">
+                <a:ln>
+                  <a:noFill/>
+                </a:ln>
+                <a:solidFill>
+                  <a:schemeClr val="tx1"/>
+                </a:solidFill>
+                <a:effectLst/>
+                <a:latin typeface="Arial" panose="020B0604020202020204" pitchFamily="34" charset="0"/>
+              </a:rPr>
+              <a:t> Data</a:t>
+            </a:r>
+            <a:r>
+              <a:rPr kumimoji="0" lang="en-US" altLang="en-US" sz="2000" b="0" i="0" u="none" strike="noStrike" cap="none" normalizeH="0" baseline="0" dirty="0">
+                <a:ln>
+                  <a:noFill/>
+                </a:ln>
+                <a:solidFill>
+                  <a:schemeClr val="tx1"/>
+                </a:solidFill>
+                <a:effectLst/>
+                <a:latin typeface="Arial" panose="020B0604020202020204" pitchFamily="34" charset="0"/>
+              </a:rPr>
+              <a:t> is what we work on.</a:t>
+            </a:r>
+          </a:p>
+          <a:p>
+            <a:pPr marL="0" marR="0" lvl="0" indent="0" algn="l" defTabSz="914400" rtl="0" eaLnBrk="0" fontAlgn="base" latinLnBrk="0" hangingPunct="0">
+              <a:lnSpc>
+                <a:spcPct val="100000"/>
+              </a:lnSpc>
+              <a:spcBef>
+                <a:spcPct val="0"/>
+              </a:spcBef>
+              <a:spcAft>
+                <a:spcPct val="0"/>
+              </a:spcAft>
+              <a:buClrTx/>
+              <a:buSzTx/>
+              <a:tabLst/>
+            </a:pPr>
+            <a:endParaRPr kumimoji="0" lang="en-US" altLang="en-US" sz="2000" b="0" i="0" u="none" strike="noStrike" cap="none" normalizeH="0" baseline="0" dirty="0">
+              <a:ln>
+                <a:noFill/>
+              </a:ln>
+              <a:solidFill>
+                <a:schemeClr val="tx1"/>
+              </a:solidFill>
+              <a:effectLst/>
+              <a:latin typeface="Arial" panose="020B0604020202020204" pitchFamily="34" charset="0"/>
+            </a:endParaRPr>
+          </a:p>
+          <a:p>
+            <a:pPr marL="0" marR="0" lvl="0" indent="0" algn="l" defTabSz="914400" rtl="0" eaLnBrk="0" fontAlgn="base" latinLnBrk="0" hangingPunct="0">
+              <a:lnSpc>
+                <a:spcPct val="100000"/>
+              </a:lnSpc>
+              <a:spcBef>
+                <a:spcPct val="0"/>
+              </a:spcBef>
+              <a:spcAft>
+                <a:spcPct val="0"/>
+              </a:spcAft>
+              <a:buClrTx/>
+              <a:buSzTx/>
+              <a:buFontTx/>
+              <a:buChar char="•"/>
+              <a:tabLst/>
+            </a:pPr>
+            <a:r>
+              <a:rPr kumimoji="0" lang="en-US" altLang="en-US" sz="2000" b="1" i="0" u="none" strike="noStrike" cap="none" normalizeH="0" baseline="0" dirty="0">
+                <a:ln>
+                  <a:noFill/>
+                </a:ln>
+                <a:solidFill>
+                  <a:schemeClr val="tx1"/>
+                </a:solidFill>
+                <a:effectLst/>
+                <a:latin typeface="Arial" panose="020B0604020202020204" pitchFamily="34" charset="0"/>
+              </a:rPr>
+              <a:t> Data Structures</a:t>
+            </a:r>
+            <a:r>
+              <a:rPr kumimoji="0" lang="en-US" altLang="en-US" sz="2000" b="0" i="0" u="none" strike="noStrike" cap="none" normalizeH="0" baseline="0" dirty="0">
+                <a:ln>
+                  <a:noFill/>
+                </a:ln>
+                <a:solidFill>
+                  <a:schemeClr val="tx1"/>
+                </a:solidFill>
+                <a:effectLst/>
+                <a:latin typeface="Arial" panose="020B0604020202020204" pitchFamily="34" charset="0"/>
+              </a:rPr>
+              <a:t> organize the data.</a:t>
+            </a:r>
+          </a:p>
+          <a:p>
+            <a:pPr marL="0" marR="0" lvl="0" indent="0" algn="l" defTabSz="914400" rtl="0" eaLnBrk="0" fontAlgn="base" latinLnBrk="0" hangingPunct="0">
+              <a:lnSpc>
+                <a:spcPct val="100000"/>
+              </a:lnSpc>
+              <a:spcBef>
+                <a:spcPct val="0"/>
+              </a:spcBef>
+              <a:spcAft>
+                <a:spcPct val="0"/>
+              </a:spcAft>
+              <a:buClrTx/>
+              <a:buSzTx/>
+              <a:tabLst/>
+            </a:pPr>
+            <a:endParaRPr kumimoji="0" lang="en-US" altLang="en-US" sz="2000" b="0" i="0" u="none" strike="noStrike" cap="none" normalizeH="0" baseline="0" dirty="0">
+              <a:ln>
+                <a:noFill/>
+              </a:ln>
+              <a:solidFill>
+                <a:schemeClr val="tx1"/>
+              </a:solidFill>
+              <a:effectLst/>
+              <a:latin typeface="Arial" panose="020B0604020202020204" pitchFamily="34" charset="0"/>
+            </a:endParaRPr>
+          </a:p>
+          <a:p>
+            <a:pPr marL="0" marR="0" lvl="0" indent="0" algn="l" defTabSz="914400" rtl="0" eaLnBrk="0" fontAlgn="base" latinLnBrk="0" hangingPunct="0">
+              <a:lnSpc>
+                <a:spcPct val="100000"/>
+              </a:lnSpc>
+              <a:spcBef>
+                <a:spcPct val="0"/>
+              </a:spcBef>
+              <a:spcAft>
+                <a:spcPct val="0"/>
+              </a:spcAft>
+              <a:buClrTx/>
+              <a:buSzTx/>
+              <a:buFontTx/>
+              <a:buChar char="•"/>
+              <a:tabLst/>
+            </a:pPr>
+            <a:r>
+              <a:rPr kumimoji="0" lang="en-US" altLang="en-US" sz="2000" b="1" i="0" u="none" strike="noStrike" cap="none" normalizeH="0" baseline="0" dirty="0">
+                <a:ln>
+                  <a:noFill/>
+                </a:ln>
+                <a:solidFill>
+                  <a:schemeClr val="tx1"/>
+                </a:solidFill>
+                <a:effectLst/>
+                <a:latin typeface="Arial" panose="020B0604020202020204" pitchFamily="34" charset="0"/>
+              </a:rPr>
+              <a:t> Algorithms</a:t>
+            </a:r>
+            <a:r>
+              <a:rPr kumimoji="0" lang="en-US" altLang="en-US" sz="2000" b="0" i="0" u="none" strike="noStrike" cap="none" normalizeH="0" baseline="0" dirty="0">
+                <a:ln>
+                  <a:noFill/>
+                </a:ln>
+                <a:solidFill>
+                  <a:schemeClr val="tx1"/>
+                </a:solidFill>
+                <a:effectLst/>
+                <a:latin typeface="Arial" panose="020B0604020202020204" pitchFamily="34" charset="0"/>
+              </a:rPr>
+              <a:t> perform actions on data (like searching, sorting, etc.).</a:t>
+            </a:r>
+          </a:p>
+        </p:txBody>
+      </p:sp>
+    </p:spTree>
+    <p:extLst>
+      <p:ext uri="{BB962C8B-B14F-4D97-AF65-F5344CB8AC3E}">
+        <p14:creationId xmlns:p14="http://schemas.microsoft.com/office/powerpoint/2010/main" val="4131242576"/>
+      </p:ext>
+    </p:extLst>
+  </p:cSld>
+  <p:clrMapOvr>
+    <a:masterClrMapping/>
+  </p:clrMapOvr>
+</p:sld>
+</file>
+
+<file path=ppt/slides/slide9.xml><?xml version="1.0" encoding="utf-8"?>
+<p:sld xmlns:a="http://schemas.openxmlformats.org/drawingml/2006/main" xmlns:r="http://schemas.openxmlformats.org/officeDocument/2006/relationships" xmlns:p="http://schemas.openxmlformats.org/presentationml/2006/main">
+  <p:cSld>
+    <p:spTree>
+      <p:nvGrpSpPr>
+        <p:cNvPr id="1" name=""/>
+        <p:cNvGrpSpPr/>
+        <p:nvPr/>
+      </p:nvGrpSpPr>
+      <p:grpSpPr>
+        <a:xfrm>
+          <a:off x="0" y="0"/>
+          <a:ext cx="0" cy="0"/>
+          <a:chOff x="0" y="0"/>
+          <a:chExt cx="0" cy="0"/>
+        </a:xfrm>
+      </p:grpSpPr>
+      <p:sp>
+        <p:nvSpPr>
+          <p:cNvPr id="2" name="Title 1">
+            <a:extLst>
+              <a:ext uri="{FF2B5EF4-FFF2-40B4-BE49-F238E27FC236}">
+                <a16:creationId xmlns:a16="http://schemas.microsoft.com/office/drawing/2014/main" id="{9A032B8F-D1A3-87B7-C58F-1062213E0C15}"/>
+              </a:ext>
+            </a:extLst>
+          </p:cNvPr>
+          <p:cNvSpPr>
+            <a:spLocks noGrp="1"/>
+          </p:cNvSpPr>
+          <p:nvPr>
+            <p:ph type="title"/>
+          </p:nvPr>
+        </p:nvSpPr>
+        <p:spPr/>
+        <p:txBody>
+          <a:bodyPr/>
+          <a:lstStyle/>
+          <a:p>
+            <a:pPr algn="ctr"/>
+            <a:r>
+              <a:rPr lang="en-US" b="1" u="sng" dirty="0"/>
+              <a:t>Flowchart Building Blocks</a:t>
+            </a:r>
+          </a:p>
+        </p:txBody>
+      </p:sp>
+      <p:pic>
+        <p:nvPicPr>
+          <p:cNvPr id="5122" name="Picture 2" descr="Basic flowchart symbols">
+            <a:extLst>
+              <a:ext uri="{FF2B5EF4-FFF2-40B4-BE49-F238E27FC236}">
+                <a16:creationId xmlns:a16="http://schemas.microsoft.com/office/drawing/2014/main" id="{5395C251-4427-85C0-4F9F-40A9297C36D9}"/>
+              </a:ext>
+            </a:extLst>
+          </p:cNvPr>
+          <p:cNvPicPr>
+            <a:picLocks noChangeAspect="1" noChangeArrowheads="1"/>
+          </p:cNvPicPr>
+          <p:nvPr/>
+        </p:nvPicPr>
+        <p:blipFill>
+          <a:blip r:embed="rId2">
+            <a:extLst>
+              <a:ext uri="{28A0092B-C50C-407E-A947-70E740481C1C}">
+                <a14:useLocalDpi xmlns:a14="http://schemas.microsoft.com/office/drawing/2010/main" val="0"/>
+              </a:ext>
+            </a:extLst>
+          </a:blip>
+          <a:srcRect/>
+          <a:stretch>
+            <a:fillRect/>
+          </a:stretch>
+        </p:blipFill>
+        <p:spPr bwMode="auto">
+          <a:xfrm>
+            <a:off x="838200" y="1690688"/>
+            <a:ext cx="6667500" cy="4324350"/>
+          </a:xfrm>
+          <a:prstGeom prst="rect">
+            <a:avLst/>
+          </a:prstGeom>
+          <a:noFill/>
+          <a:extLst>
+            <a:ext uri="{909E8E84-426E-40DD-AFC4-6F175D3DCCD1}">
+              <a14:hiddenFill xmlns:a14="http://schemas.microsoft.com/office/drawing/2010/main">
+                <a:solidFill>
+                  <a:srgbClr val="FFFFFF"/>
+                </a:solidFill>
+              </a14:hiddenFill>
+            </a:ext>
+          </a:extLst>
+        </p:spPr>
+      </p:pic>
+      <p:pic>
+        <p:nvPicPr>
+          <p:cNvPr id="6" name="Picture 5">
+            <a:extLst>
+              <a:ext uri="{FF2B5EF4-FFF2-40B4-BE49-F238E27FC236}">
+                <a16:creationId xmlns:a16="http://schemas.microsoft.com/office/drawing/2014/main" id="{A226704E-0535-AF21-86EB-5F810CE90B92}"/>
+              </a:ext>
+            </a:extLst>
+          </p:cNvPr>
+          <p:cNvPicPr>
+            <a:picLocks noChangeAspect="1"/>
+          </p:cNvPicPr>
+          <p:nvPr/>
+        </p:nvPicPr>
+        <p:blipFill>
+          <a:blip r:embed="rId3"/>
+          <a:stretch>
+            <a:fillRect/>
+          </a:stretch>
+        </p:blipFill>
+        <p:spPr>
+          <a:xfrm>
+            <a:off x="8251655" y="1690688"/>
+            <a:ext cx="2975721" cy="4324350"/>
+          </a:xfrm>
+          <a:prstGeom prst="rect">
+            <a:avLst/>
+          </a:prstGeom>
+        </p:spPr>
+      </p:pic>
+    </p:spTree>
+    <p:extLst>
+      <p:ext uri="{BB962C8B-B14F-4D97-AF65-F5344CB8AC3E}">
+        <p14:creationId xmlns:p14="http://schemas.microsoft.com/office/powerpoint/2010/main" val="2205953005"/>
       </p:ext>
     </p:extLst>
   </p:cSld>

</xml_diff>